<commit_message>
Pitch deck (static): remove all animations and slide transitions
Co-Authored-By: Claude Opus 5.5 <noreply@anthropic.com>
</commit_message>
<xml_diff>
--- a/research/Mutz_Pitch_lean_static.pptx
+++ b/research/Mutz_Pitch_lean_static.pptx
@@ -7057,98 +7057,6 @@
   <p:clrMapOvr>
     <a:masterClrMapping/>
   </p:clrMapOvr>
-  <p:transition spd="med">
-    <p:fade/>
-  </p:transition>
-  <p:timing>
-    <p:tnLst>
-      <p:par>
-        <p:cTn id="1" dur="indefinite" restart="never" nodeType="tmRoot">
-          <p:childTnLst>
-            <p:seq concurrent="1" nextAc="seek">
-              <p:cTn id="2" dur="indefinite" nodeType="mainSeq">
-                <p:childTnLst>
-                  <p:par>
-                    <p:cTn id="3" fill="hold">
-                      <p:stCondLst>
-                        <p:cond delay="indefinite"/>
-                        <p:cond evt="onBegin" delay="0">
-                          <p:tn val="2"/>
-                        </p:cond>
-                      </p:stCondLst>
-                      <p:childTnLst>
-                        <p:par>
-                          <p:cTn id="4" fill="hold">
-                            <p:stCondLst>
-                              <p:cond delay="0"/>
-                            </p:stCondLst>
-                            <p:childTnLst>
-                              <p:par>
-                                <p:cTn id="5" presetID="10" presetClass="entr" presetSubtype="0" fill="hold" grpId="0" nodeType="afterEffect">
-                                  <p:stCondLst>
-                                    <p:cond delay="900"/>
-                                  </p:stCondLst>
-                                  <p:childTnLst>
-                                    <p:set>
-                                      <p:cBhvr>
-                                        <p:cTn id="6" dur="1" fill="hold">
-                                          <p:stCondLst>
-                                            <p:cond delay="0"/>
-                                          </p:stCondLst>
-                                        </p:cTn>
-                                        <p:tgtEl>
-                                          <p:spTgt spid="3"/>
-                                        </p:tgtEl>
-                                        <p:attrNameLst>
-                                          <p:attrName>style.visibility</p:attrName>
-                                        </p:attrNameLst>
-                                      </p:cBhvr>
-                                      <p:to>
-                                        <p:strVal val="visible"/>
-                                      </p:to>
-                                    </p:set>
-                                    <p:animEffect transition="in" filter="fade">
-                                      <p:cBhvr>
-                                        <p:cTn id="7" dur="500"/>
-                                        <p:tgtEl>
-                                          <p:spTgt spid="3"/>
-                                        </p:tgtEl>
-                                      </p:cBhvr>
-                                    </p:animEffect>
-                                  </p:childTnLst>
-                                </p:cTn>
-                              </p:par>
-                            </p:childTnLst>
-                          </p:cTn>
-                        </p:par>
-                      </p:childTnLst>
-                    </p:cTn>
-                  </p:par>
-                </p:childTnLst>
-              </p:cTn>
-              <p:prevCondLst>
-                <p:cond evt="onPrev" delay="0">
-                  <p:tgtEl>
-                    <p:sldTgt/>
-                  </p:tgtEl>
-                </p:cond>
-              </p:prevCondLst>
-              <p:nextCondLst>
-                <p:cond evt="onNext" delay="0">
-                  <p:tgtEl>
-                    <p:sldTgt/>
-                  </p:tgtEl>
-                </p:cond>
-              </p:nextCondLst>
-            </p:seq>
-          </p:childTnLst>
-        </p:cTn>
-      </p:par>
-    </p:tnLst>
-    <p:bldLst>
-      <p:bldP spid="3" grpId="0" animBg="1"/>
-    </p:bldLst>
-  </p:timing>
 </p:sld>
 </file>
 
@@ -7702,9 +7610,6 @@
   <p:clrMapOvr>
     <a:masterClrMapping/>
   </p:clrMapOvr>
-  <p:transition spd="med">
-    <p:fade/>
-  </p:transition>
 </p:sld>
 </file>
 
@@ -7825,9 +7730,6 @@
   <p:clrMapOvr>
     <a:masterClrMapping/>
   </p:clrMapOvr>
-  <p:transition spd="med">
-    <p:fade/>
-  </p:transition>
 </p:sld>
 </file>
 
@@ -9509,9 +9411,6 @@
   <p:clrMapOvr>
     <a:masterClrMapping/>
   </p:clrMapOvr>
-  <p:transition spd="med">
-    <p:fade/>
-  </p:transition>
 </p:sld>
 </file>
 
@@ -10180,9 +10079,6 @@
   <p:clrMapOvr>
     <a:masterClrMapping/>
   </p:clrMapOvr>
-  <p:transition spd="med">
-    <p:fade/>
-  </p:transition>
 </p:sld>
 </file>
 
@@ -10963,9 +10859,6 @@
   <p:clrMapOvr>
     <a:masterClrMapping/>
   </p:clrMapOvr>
-  <p:transition spd="med">
-    <p:fade/>
-  </p:transition>
 </p:sld>
 </file>
 
@@ -12482,9 +12375,6 @@
   <p:clrMapOvr>
     <a:masterClrMapping/>
   </p:clrMapOvr>
-  <p:transition spd="med">
-    <p:fade/>
-  </p:transition>
 </p:sld>
 </file>
 
@@ -13778,9 +13668,6 @@
   <p:clrMapOvr>
     <a:masterClrMapping/>
   </p:clrMapOvr>
-  <p:transition spd="med">
-    <p:fade/>
-  </p:transition>
 </p:sld>
 </file>
 
@@ -14331,9 +14218,6 @@
   <p:clrMapOvr>
     <a:masterClrMapping/>
   </p:clrMapOvr>
-  <p:transition spd="med">
-    <p:fade/>
-  </p:transition>
 </p:sld>
 </file>
 
@@ -15059,9 +14943,6 @@
   <p:clrMapOvr>
     <a:masterClrMapping/>
   </p:clrMapOvr>
-  <p:transition spd="med">
-    <p:fade/>
-  </p:transition>
 </p:sld>
 </file>
 
@@ -16432,9 +16313,6 @@
   <p:clrMapOvr>
     <a:masterClrMapping/>
   </p:clrMapOvr>
-  <p:transition spd="med">
-    <p:fade/>
-  </p:transition>
 </p:sld>
 </file>
 
@@ -16650,134 +16528,6 @@
   <p:clrMapOvr>
     <a:masterClrMapping/>
   </p:clrMapOvr>
-  <p:transition spd="med">
-    <p:fade/>
-  </p:transition>
-  <p:timing>
-    <p:tnLst>
-      <p:par>
-        <p:cTn id="1" dur="indefinite" restart="never" nodeType="tmRoot">
-          <p:childTnLst>
-            <p:seq concurrent="1" nextAc="seek">
-              <p:cTn id="2" dur="indefinite" nodeType="mainSeq">
-                <p:childTnLst>
-                  <p:par>
-                    <p:cTn id="3" fill="hold">
-                      <p:stCondLst>
-                        <p:cond delay="indefinite"/>
-                        <p:cond evt="onBegin" delay="0">
-                          <p:tn val="2"/>
-                        </p:cond>
-                      </p:stCondLst>
-                      <p:childTnLst>
-                        <p:par>
-                          <p:cTn id="4" fill="hold">
-                            <p:stCondLst>
-                              <p:cond delay="0"/>
-                            </p:stCondLst>
-                            <p:childTnLst>
-                              <p:par>
-                                <p:cTn id="5" presetID="10" presetClass="entr" presetSubtype="0" fill="hold" grpId="0" nodeType="afterEffect">
-                                  <p:stCondLst>
-                                    <p:cond delay="1700"/>
-                                  </p:stCondLst>
-                                  <p:childTnLst>
-                                    <p:set>
-                                      <p:cBhvr>
-                                        <p:cTn id="6" dur="1" fill="hold">
-                                          <p:stCondLst>
-                                            <p:cond delay="0"/>
-                                          </p:stCondLst>
-                                        </p:cTn>
-                                        <p:tgtEl>
-                                          <p:spTgt spid="904"/>
-                                        </p:tgtEl>
-                                        <p:attrNameLst>
-                                          <p:attrName>style.visibility</p:attrName>
-                                        </p:attrNameLst>
-                                      </p:cBhvr>
-                                      <p:to>
-                                        <p:strVal val="visible"/>
-                                      </p:to>
-                                    </p:set>
-                                    <p:animEffect transition="in" filter="fade">
-                                      <p:cBhvr>
-                                        <p:cTn id="7" dur="500"/>
-                                        <p:tgtEl>
-                                          <p:spTgt spid="904"/>
-                                        </p:tgtEl>
-                                      </p:cBhvr>
-                                    </p:animEffect>
-                                  </p:childTnLst>
-                                </p:cTn>
-                              </p:par>
-                              <p:par>
-                                <p:cTn id="8" presetID="10" presetClass="entr" presetSubtype="0" fill="hold" grpId="0" nodeType="withEffect">
-                                  <p:stCondLst>
-                                    <p:cond delay="2600"/>
-                                  </p:stCondLst>
-                                  <p:childTnLst>
-                                    <p:set>
-                                      <p:cBhvr>
-                                        <p:cTn id="9" dur="1" fill="hold">
-                                          <p:stCondLst>
-                                            <p:cond delay="0"/>
-                                          </p:stCondLst>
-                                        </p:cTn>
-                                        <p:tgtEl>
-                                          <p:spTgt spid="905"/>
-                                        </p:tgtEl>
-                                        <p:attrNameLst>
-                                          <p:attrName>style.visibility</p:attrName>
-                                        </p:attrNameLst>
-                                      </p:cBhvr>
-                                      <p:to>
-                                        <p:strVal val="visible"/>
-                                      </p:to>
-                                    </p:set>
-                                    <p:animEffect transition="in" filter="fade">
-                                      <p:cBhvr>
-                                        <p:cTn id="10" dur="500"/>
-                                        <p:tgtEl>
-                                          <p:spTgt spid="905"/>
-                                        </p:tgtEl>
-                                      </p:cBhvr>
-                                    </p:animEffect>
-                                  </p:childTnLst>
-                                </p:cTn>
-                              </p:par>
-                            </p:childTnLst>
-                          </p:cTn>
-                        </p:par>
-                      </p:childTnLst>
-                    </p:cTn>
-                  </p:par>
-                </p:childTnLst>
-              </p:cTn>
-              <p:prevCondLst>
-                <p:cond evt="onPrev" delay="0">
-                  <p:tgtEl>
-                    <p:sldTgt/>
-                  </p:tgtEl>
-                </p:cond>
-              </p:prevCondLst>
-              <p:nextCondLst>
-                <p:cond evt="onNext" delay="0">
-                  <p:tgtEl>
-                    <p:sldTgt/>
-                  </p:tgtEl>
-                </p:cond>
-              </p:nextCondLst>
-            </p:seq>
-          </p:childTnLst>
-        </p:cTn>
-      </p:par>
-    </p:tnLst>
-    <p:bldLst>
-      <p:bldP spid="904" grpId="0" animBg="1"/>
-      <p:bldP spid="905" grpId="0" animBg="1"/>
-    </p:bldLst>
-  </p:timing>
 </p:sld>
 </file>
 
@@ -17569,9 +17319,6 @@
   <p:clrMapOvr>
     <a:masterClrMapping/>
   </p:clrMapOvr>
-  <p:transition spd="med">
-    <p:fade/>
-  </p:transition>
 </p:sld>
 </file>
 
@@ -17849,241 +17596,6 @@
   <p:clrMapOvr>
     <a:masterClrMapping/>
   </p:clrMapOvr>
-  <p:transition spd="med">
-    <p:fade/>
-  </p:transition>
-  <p:timing>
-    <p:tnLst>
-      <p:par>
-        <p:cTn id="1" dur="indefinite" restart="never" nodeType="tmRoot">
-          <p:childTnLst>
-            <p:seq concurrent="1" nextAc="seek">
-              <p:cTn id="2" dur="indefinite" nodeType="mainSeq">
-                <p:childTnLst>
-                  <p:par>
-                    <p:cTn id="3" fill="hold">
-                      <p:stCondLst>
-                        <p:cond delay="indefinite"/>
-                        <p:cond evt="onBegin" delay="0">
-                          <p:tn val="2"/>
-                        </p:cond>
-                      </p:stCondLst>
-                      <p:childTnLst>
-                        <p:par>
-                          <p:cTn id="4" fill="hold">
-                            <p:stCondLst>
-                              <p:cond delay="0"/>
-                            </p:stCondLst>
-                            <p:childTnLst>
-                              <p:par>
-                                <p:cTn id="5" presetID="10" presetClass="entr" presetSubtype="0" fill="hold" grpId="0" nodeType="afterEffect">
-                                  <p:stCondLst>
-                                    <p:cond delay="2600"/>
-                                  </p:stCondLst>
-                                  <p:childTnLst>
-                                    <p:set>
-                                      <p:cBhvr>
-                                        <p:cTn id="6" dur="1" fill="hold">
-                                          <p:stCondLst>
-                                            <p:cond delay="0"/>
-                                          </p:stCondLst>
-                                        </p:cTn>
-                                        <p:tgtEl>
-                                          <p:spTgt spid="904"/>
-                                        </p:tgtEl>
-                                        <p:attrNameLst>
-                                          <p:attrName>style.visibility</p:attrName>
-                                        </p:attrNameLst>
-                                      </p:cBhvr>
-                                      <p:to>
-                                        <p:strVal val="visible"/>
-                                      </p:to>
-                                    </p:set>
-                                    <p:animEffect transition="in" filter="fade">
-                                      <p:cBhvr>
-                                        <p:cTn id="7" dur="500"/>
-                                        <p:tgtEl>
-                                          <p:spTgt spid="904"/>
-                                        </p:tgtEl>
-                                      </p:cBhvr>
-                                    </p:animEffect>
-                                  </p:childTnLst>
-                                </p:cTn>
-                              </p:par>
-                              <p:par>
-                                <p:cTn id="8" presetID="10" presetClass="entr" presetSubtype="0" fill="hold" grpId="0" nodeType="withEffect">
-                                  <p:stCondLst>
-                                    <p:cond delay="4600"/>
-                                  </p:stCondLst>
-                                  <p:childTnLst>
-                                    <p:set>
-                                      <p:cBhvr>
-                                        <p:cTn id="9" dur="1" fill="hold">
-                                          <p:stCondLst>
-                                            <p:cond delay="0"/>
-                                          </p:stCondLst>
-                                        </p:cTn>
-                                        <p:tgtEl>
-                                          <p:spTgt spid="905"/>
-                                        </p:tgtEl>
-                                        <p:attrNameLst>
-                                          <p:attrName>style.visibility</p:attrName>
-                                        </p:attrNameLst>
-                                      </p:cBhvr>
-                                      <p:to>
-                                        <p:strVal val="visible"/>
-                                      </p:to>
-                                    </p:set>
-                                    <p:animEffect transition="in" filter="fade">
-                                      <p:cBhvr>
-                                        <p:cTn id="10" dur="500"/>
-                                        <p:tgtEl>
-                                          <p:spTgt spid="905"/>
-                                        </p:tgtEl>
-                                      </p:cBhvr>
-                                    </p:animEffect>
-                                  </p:childTnLst>
-                                </p:cTn>
-                              </p:par>
-                              <p:par>
-                                <p:cTn id="11" presetID="10" presetClass="entr" presetSubtype="0" fill="hold" grpId="0" nodeType="withEffect">
-                                  <p:stCondLst>
-                                    <p:cond delay="5600"/>
-                                  </p:stCondLst>
-                                  <p:childTnLst>
-                                    <p:set>
-                                      <p:cBhvr>
-                                        <p:cTn id="12" dur="1" fill="hold">
-                                          <p:stCondLst>
-                                            <p:cond delay="0"/>
-                                          </p:stCondLst>
-                                        </p:cTn>
-                                        <p:tgtEl>
-                                          <p:spTgt spid="906"/>
-                                        </p:tgtEl>
-                                        <p:attrNameLst>
-                                          <p:attrName>style.visibility</p:attrName>
-                                        </p:attrNameLst>
-                                      </p:cBhvr>
-                                      <p:to>
-                                        <p:strVal val="visible"/>
-                                      </p:to>
-                                    </p:set>
-                                    <p:animEffect transition="in" filter="fade">
-                                      <p:cBhvr>
-                                        <p:cTn id="13" dur="500"/>
-                                        <p:tgtEl>
-                                          <p:spTgt spid="906"/>
-                                        </p:tgtEl>
-                                      </p:cBhvr>
-                                    </p:animEffect>
-                                  </p:childTnLst>
-                                </p:cTn>
-                              </p:par>
-                              <p:par>
-                                <p:cTn id="14" presetID="10" presetClass="entr" presetSubtype="0" fill="hold" grpId="0" nodeType="withEffect">
-                                  <p:stCondLst>
-                                    <p:cond delay="5600"/>
-                                  </p:stCondLst>
-                                  <p:childTnLst>
-                                    <p:set>
-                                      <p:cBhvr>
-                                        <p:cTn id="15" dur="1" fill="hold">
-                                          <p:stCondLst>
-                                            <p:cond delay="0"/>
-                                          </p:stCondLst>
-                                        </p:cTn>
-                                        <p:tgtEl>
-                                          <p:spTgt spid="908"/>
-                                        </p:tgtEl>
-                                        <p:attrNameLst>
-                                          <p:attrName>style.visibility</p:attrName>
-                                        </p:attrNameLst>
-                                      </p:cBhvr>
-                                      <p:to>
-                                        <p:strVal val="visible"/>
-                                      </p:to>
-                                    </p:set>
-                                    <p:animEffect transition="in" filter="fade">
-                                      <p:cBhvr>
-                                        <p:cTn id="16" dur="500"/>
-                                        <p:tgtEl>
-                                          <p:spTgt spid="908"/>
-                                        </p:tgtEl>
-                                      </p:cBhvr>
-                                    </p:animEffect>
-                                  </p:childTnLst>
-                                </p:cTn>
-                              </p:par>
-                              <p:par>
-                                <p:cTn id="17" presetID="10" presetClass="entr" presetSubtype="0" fill="hold" grpId="0" nodeType="withEffect">
-                                  <p:stCondLst>
-                                    <p:cond delay="5600"/>
-                                  </p:stCondLst>
-                                  <p:childTnLst>
-                                    <p:set>
-                                      <p:cBhvr>
-                                        <p:cTn id="18" dur="1" fill="hold">
-                                          <p:stCondLst>
-                                            <p:cond delay="0"/>
-                                          </p:stCondLst>
-                                        </p:cTn>
-                                        <p:tgtEl>
-                                          <p:spTgt spid="909"/>
-                                        </p:tgtEl>
-                                        <p:attrNameLst>
-                                          <p:attrName>style.visibility</p:attrName>
-                                        </p:attrNameLst>
-                                      </p:cBhvr>
-                                      <p:to>
-                                        <p:strVal val="visible"/>
-                                      </p:to>
-                                    </p:set>
-                                    <p:animEffect transition="in" filter="fade">
-                                      <p:cBhvr>
-                                        <p:cTn id="19" dur="500"/>
-                                        <p:tgtEl>
-                                          <p:spTgt spid="909"/>
-                                        </p:tgtEl>
-                                      </p:cBhvr>
-                                    </p:animEffect>
-                                  </p:childTnLst>
-                                </p:cTn>
-                              </p:par>
-                            </p:childTnLst>
-                          </p:cTn>
-                        </p:par>
-                      </p:childTnLst>
-                    </p:cTn>
-                  </p:par>
-                </p:childTnLst>
-              </p:cTn>
-              <p:prevCondLst>
-                <p:cond evt="onPrev" delay="0">
-                  <p:tgtEl>
-                    <p:sldTgt/>
-                  </p:tgtEl>
-                </p:cond>
-              </p:prevCondLst>
-              <p:nextCondLst>
-                <p:cond evt="onNext" delay="0">
-                  <p:tgtEl>
-                    <p:sldTgt/>
-                  </p:tgtEl>
-                </p:cond>
-              </p:nextCondLst>
-            </p:seq>
-          </p:childTnLst>
-        </p:cTn>
-      </p:par>
-    </p:tnLst>
-    <p:bldLst>
-      <p:bldP spid="904" grpId="0" animBg="1"/>
-      <p:bldP spid="905" grpId="0" animBg="1"/>
-      <p:bldP spid="906" grpId="0" animBg="1"/>
-      <p:bldP spid="908" grpId="0" animBg="1"/>
-    </p:bldLst>
-  </p:timing>
 </p:sld>
 </file>
 
@@ -18299,98 +17811,6 @@
   <p:clrMapOvr>
     <a:masterClrMapping/>
   </p:clrMapOvr>
-  <p:transition spd="med">
-    <p:fade/>
-  </p:transition>
-  <p:timing>
-    <p:tnLst>
-      <p:par>
-        <p:cTn id="1" dur="indefinite" restart="never" nodeType="tmRoot">
-          <p:childTnLst>
-            <p:seq concurrent="1" nextAc="seek">
-              <p:cTn id="2" dur="indefinite" nodeType="mainSeq">
-                <p:childTnLst>
-                  <p:par>
-                    <p:cTn id="3" fill="hold">
-                      <p:stCondLst>
-                        <p:cond delay="indefinite"/>
-                        <p:cond evt="onBegin" delay="0">
-                          <p:tn val="2"/>
-                        </p:cond>
-                      </p:stCondLst>
-                      <p:childTnLst>
-                        <p:par>
-                          <p:cTn id="4" fill="hold">
-                            <p:stCondLst>
-                              <p:cond delay="0"/>
-                            </p:stCondLst>
-                            <p:childTnLst>
-                              <p:par>
-                                <p:cTn id="5" presetID="10" presetClass="entr" presetSubtype="0" fill="hold" grpId="0" nodeType="afterEffect">
-                                  <p:stCondLst>
-                                    <p:cond delay="1300"/>
-                                  </p:stCondLst>
-                                  <p:childTnLst>
-                                    <p:set>
-                                      <p:cBhvr>
-                                        <p:cTn id="6" dur="1" fill="hold">
-                                          <p:stCondLst>
-                                            <p:cond delay="0"/>
-                                          </p:stCondLst>
-                                        </p:cTn>
-                                        <p:tgtEl>
-                                          <p:spTgt spid="905"/>
-                                        </p:tgtEl>
-                                        <p:attrNameLst>
-                                          <p:attrName>style.visibility</p:attrName>
-                                        </p:attrNameLst>
-                                      </p:cBhvr>
-                                      <p:to>
-                                        <p:strVal val="visible"/>
-                                      </p:to>
-                                    </p:set>
-                                    <p:animEffect transition="in" filter="fade">
-                                      <p:cBhvr>
-                                        <p:cTn id="7" dur="500"/>
-                                        <p:tgtEl>
-                                          <p:spTgt spid="905"/>
-                                        </p:tgtEl>
-                                      </p:cBhvr>
-                                    </p:animEffect>
-                                  </p:childTnLst>
-                                </p:cTn>
-                              </p:par>
-                            </p:childTnLst>
-                          </p:cTn>
-                        </p:par>
-                      </p:childTnLst>
-                    </p:cTn>
-                  </p:par>
-                </p:childTnLst>
-              </p:cTn>
-              <p:prevCondLst>
-                <p:cond evt="onPrev" delay="0">
-                  <p:tgtEl>
-                    <p:sldTgt/>
-                  </p:tgtEl>
-                </p:cond>
-              </p:prevCondLst>
-              <p:nextCondLst>
-                <p:cond evt="onNext" delay="0">
-                  <p:tgtEl>
-                    <p:sldTgt/>
-                  </p:tgtEl>
-                </p:cond>
-              </p:nextCondLst>
-            </p:seq>
-          </p:childTnLst>
-        </p:cTn>
-      </p:par>
-    </p:tnLst>
-    <p:bldLst>
-      <p:bldP spid="905" grpId="0" animBg="1"/>
-    </p:bldLst>
-  </p:timing>
 </p:sld>
 </file>
 
@@ -18545,9 +17965,6 @@
   <p:clrMapOvr>
     <a:masterClrMapping/>
   </p:clrMapOvr>
-  <p:transition spd="med">
-    <p:fade/>
-  </p:transition>
 </p:sld>
 </file>
 
@@ -18942,206 +18359,6 @@
   <p:clrMapOvr>
     <a:masterClrMapping/>
   </p:clrMapOvr>
-  <p:transition spd="med">
-    <p:fade/>
-  </p:transition>
-  <p:timing>
-    <p:tnLst>
-      <p:par>
-        <p:cTn id="1" dur="indefinite" restart="never" nodeType="tmRoot">
-          <p:childTnLst>
-            <p:seq concurrent="1" nextAc="seek">
-              <p:cTn id="2" dur="indefinite" nodeType="mainSeq">
-                <p:childTnLst>
-                  <p:par>
-                    <p:cTn id="3" fill="hold">
-                      <p:stCondLst>
-                        <p:cond delay="indefinite"/>
-                        <p:cond evt="onBegin" delay="0">
-                          <p:tn val="2"/>
-                        </p:cond>
-                      </p:stCondLst>
-                      <p:childTnLst>
-                        <p:par>
-                          <p:cTn id="4" fill="hold">
-                            <p:stCondLst>
-                              <p:cond delay="0"/>
-                            </p:stCondLst>
-                            <p:childTnLst>
-                              <p:par>
-                                <p:cTn id="5" presetID="10" presetClass="entr" presetSubtype="0" fill="hold" grpId="0" nodeType="afterEffect">
-                                  <p:stCondLst>
-                                    <p:cond delay="2000"/>
-                                  </p:stCondLst>
-                                  <p:childTnLst>
-                                    <p:set>
-                                      <p:cBhvr>
-                                        <p:cTn id="6" dur="1" fill="hold">
-                                          <p:stCondLst>
-                                            <p:cond delay="0"/>
-                                          </p:stCondLst>
-                                        </p:cTn>
-                                        <p:tgtEl>
-                                          <p:spTgt spid="904"/>
-                                        </p:tgtEl>
-                                        <p:attrNameLst>
-                                          <p:attrName>style.visibility</p:attrName>
-                                        </p:attrNameLst>
-                                      </p:cBhvr>
-                                      <p:to>
-                                        <p:strVal val="visible"/>
-                                      </p:to>
-                                    </p:set>
-                                    <p:animEffect transition="in" filter="fade">
-                                      <p:cBhvr>
-                                        <p:cTn id="7" dur="500"/>
-                                        <p:tgtEl>
-                                          <p:spTgt spid="904"/>
-                                        </p:tgtEl>
-                                      </p:cBhvr>
-                                    </p:animEffect>
-                                  </p:childTnLst>
-                                </p:cTn>
-                              </p:par>
-                              <p:par>
-                                <p:cTn id="8" presetID="10" presetClass="entr" presetSubtype="0" fill="hold" grpId="0" nodeType="withEffect">
-                                  <p:stCondLst>
-                                    <p:cond delay="3000"/>
-                                  </p:stCondLst>
-                                  <p:childTnLst>
-                                    <p:set>
-                                      <p:cBhvr>
-                                        <p:cTn id="9" dur="1" fill="hold">
-                                          <p:stCondLst>
-                                            <p:cond delay="0"/>
-                                          </p:stCondLst>
-                                        </p:cTn>
-                                        <p:tgtEl>
-                                          <p:spTgt spid="905"/>
-                                        </p:tgtEl>
-                                        <p:attrNameLst>
-                                          <p:attrName>style.visibility</p:attrName>
-                                        </p:attrNameLst>
-                                      </p:cBhvr>
-                                      <p:to>
-                                        <p:strVal val="visible"/>
-                                      </p:to>
-                                    </p:set>
-                                    <p:animEffect transition="in" filter="fade">
-                                      <p:cBhvr>
-                                        <p:cTn id="10" dur="500"/>
-                                        <p:tgtEl>
-                                          <p:spTgt spid="905"/>
-                                        </p:tgtEl>
-                                      </p:cBhvr>
-                                    </p:animEffect>
-                                  </p:childTnLst>
-                                </p:cTn>
-                              </p:par>
-                              <p:par>
-                                <p:cTn id="11" presetID="10" presetClass="entr" presetSubtype="0" fill="hold" grpId="0" nodeType="withEffect">
-                                  <p:stCondLst>
-                                    <p:cond delay="4500"/>
-                                  </p:stCondLst>
-                                  <p:childTnLst>
-                                    <p:set>
-                                      <p:cBhvr>
-                                        <p:cTn id="12" dur="1" fill="hold">
-                                          <p:stCondLst>
-                                            <p:cond delay="0"/>
-                                          </p:stCondLst>
-                                        </p:cTn>
-                                        <p:tgtEl>
-                                          <p:spTgt spid="906"/>
-                                        </p:tgtEl>
-                                        <p:attrNameLst>
-                                          <p:attrName>style.visibility</p:attrName>
-                                        </p:attrNameLst>
-                                      </p:cBhvr>
-                                      <p:to>
-                                        <p:strVal val="visible"/>
-                                      </p:to>
-                                    </p:set>
-                                    <p:animEffect transition="in" filter="fade">
-                                      <p:cBhvr>
-                                        <p:cTn id="13" dur="500"/>
-                                        <p:tgtEl>
-                                          <p:spTgt spid="906"/>
-                                        </p:tgtEl>
-                                      </p:cBhvr>
-                                    </p:animEffect>
-                                  </p:childTnLst>
-                                </p:cTn>
-                              </p:par>
-                              <p:par>
-                                <p:cTn id="14" presetID="10" presetClass="entr" presetSubtype="0" fill="hold" grpId="0" nodeType="withEffect">
-                                  <p:stCondLst>
-                                    <p:cond delay="5400"/>
-                                  </p:stCondLst>
-                                  <p:childTnLst>
-                                    <p:set>
-                                      <p:cBhvr>
-                                        <p:cTn id="15" dur="1" fill="hold">
-                                          <p:stCondLst>
-                                            <p:cond delay="0"/>
-                                          </p:stCondLst>
-                                        </p:cTn>
-                                        <p:tgtEl>
-                                          <p:spTgt spid="907"/>
-                                        </p:tgtEl>
-                                        <p:attrNameLst>
-                                          <p:attrName>style.visibility</p:attrName>
-                                        </p:attrNameLst>
-                                      </p:cBhvr>
-                                      <p:to>
-                                        <p:strVal val="visible"/>
-                                      </p:to>
-                                    </p:set>
-                                    <p:animEffect transition="in" filter="fade">
-                                      <p:cBhvr>
-                                        <p:cTn id="16" dur="500"/>
-                                        <p:tgtEl>
-                                          <p:spTgt spid="907"/>
-                                        </p:tgtEl>
-                                      </p:cBhvr>
-                                    </p:animEffect>
-                                  </p:childTnLst>
-                                </p:cTn>
-                              </p:par>
-                            </p:childTnLst>
-                          </p:cTn>
-                        </p:par>
-                      </p:childTnLst>
-                    </p:cTn>
-                  </p:par>
-                </p:childTnLst>
-              </p:cTn>
-              <p:prevCondLst>
-                <p:cond evt="onPrev" delay="0">
-                  <p:tgtEl>
-                    <p:sldTgt/>
-                  </p:tgtEl>
-                </p:cond>
-              </p:prevCondLst>
-              <p:nextCondLst>
-                <p:cond evt="onNext" delay="0">
-                  <p:tgtEl>
-                    <p:sldTgt/>
-                  </p:tgtEl>
-                </p:cond>
-              </p:nextCondLst>
-            </p:seq>
-          </p:childTnLst>
-        </p:cTn>
-      </p:par>
-    </p:tnLst>
-    <p:bldLst>
-      <p:bldP spid="904" grpId="0" animBg="1"/>
-      <p:bldP spid="905" grpId="0" animBg="1"/>
-      <p:bldP spid="906" grpId="0" animBg="1"/>
-      <p:bldP spid="907" grpId="0" animBg="1"/>
-    </p:bldLst>
-  </p:timing>
 </p:sld>
 </file>
 
@@ -19416,206 +18633,6 @@
   <p:clrMapOvr>
     <a:masterClrMapping/>
   </p:clrMapOvr>
-  <p:transition spd="med">
-    <p:fade/>
-  </p:transition>
-  <p:timing>
-    <p:tnLst>
-      <p:par>
-        <p:cTn id="1" dur="indefinite" restart="never" nodeType="tmRoot">
-          <p:childTnLst>
-            <p:seq concurrent="1" nextAc="seek">
-              <p:cTn id="2" dur="indefinite" nodeType="mainSeq">
-                <p:childTnLst>
-                  <p:par>
-                    <p:cTn id="3" fill="hold">
-                      <p:stCondLst>
-                        <p:cond delay="indefinite"/>
-                        <p:cond evt="onBegin" delay="0">
-                          <p:tn val="2"/>
-                        </p:cond>
-                      </p:stCondLst>
-                      <p:childTnLst>
-                        <p:par>
-                          <p:cTn id="4" fill="hold">
-                            <p:stCondLst>
-                              <p:cond delay="0"/>
-                            </p:stCondLst>
-                            <p:childTnLst>
-                              <p:par>
-                                <p:cTn id="5" presetID="10" presetClass="entr" presetSubtype="0" fill="hold" grpId="0" nodeType="afterEffect">
-                                  <p:stCondLst>
-                                    <p:cond delay="1900"/>
-                                  </p:stCondLst>
-                                  <p:childTnLst>
-                                    <p:set>
-                                      <p:cBhvr>
-                                        <p:cTn id="6" dur="1" fill="hold">
-                                          <p:stCondLst>
-                                            <p:cond delay="0"/>
-                                          </p:stCondLst>
-                                        </p:cTn>
-                                        <p:tgtEl>
-                                          <p:spTgt spid="904"/>
-                                        </p:tgtEl>
-                                        <p:attrNameLst>
-                                          <p:attrName>style.visibility</p:attrName>
-                                        </p:attrNameLst>
-                                      </p:cBhvr>
-                                      <p:to>
-                                        <p:strVal val="visible"/>
-                                      </p:to>
-                                    </p:set>
-                                    <p:animEffect transition="in" filter="fade">
-                                      <p:cBhvr>
-                                        <p:cTn id="7" dur="500"/>
-                                        <p:tgtEl>
-                                          <p:spTgt spid="904"/>
-                                        </p:tgtEl>
-                                      </p:cBhvr>
-                                    </p:animEffect>
-                                  </p:childTnLst>
-                                </p:cTn>
-                              </p:par>
-                              <p:par>
-                                <p:cTn id="8" presetID="10" presetClass="entr" presetSubtype="0" fill="hold" grpId="0" nodeType="withEffect">
-                                  <p:stCondLst>
-                                    <p:cond delay="1900"/>
-                                  </p:stCondLst>
-                                  <p:childTnLst>
-                                    <p:set>
-                                      <p:cBhvr>
-                                        <p:cTn id="9" dur="1" fill="hold">
-                                          <p:stCondLst>
-                                            <p:cond delay="0"/>
-                                          </p:stCondLst>
-                                        </p:cTn>
-                                        <p:tgtEl>
-                                          <p:spTgt spid="905"/>
-                                        </p:tgtEl>
-                                        <p:attrNameLst>
-                                          <p:attrName>style.visibility</p:attrName>
-                                        </p:attrNameLst>
-                                      </p:cBhvr>
-                                      <p:to>
-                                        <p:strVal val="visible"/>
-                                      </p:to>
-                                    </p:set>
-                                    <p:animEffect transition="in" filter="fade">
-                                      <p:cBhvr>
-                                        <p:cTn id="10" dur="500"/>
-                                        <p:tgtEl>
-                                          <p:spTgt spid="905"/>
-                                        </p:tgtEl>
-                                      </p:cBhvr>
-                                    </p:animEffect>
-                                  </p:childTnLst>
-                                </p:cTn>
-                              </p:par>
-                              <p:par>
-                                <p:cTn id="11" presetID="10" presetClass="entr" presetSubtype="0" fill="hold" grpId="0" nodeType="withEffect">
-                                  <p:stCondLst>
-                                    <p:cond delay="3200"/>
-                                  </p:stCondLst>
-                                  <p:childTnLst>
-                                    <p:set>
-                                      <p:cBhvr>
-                                        <p:cTn id="12" dur="1" fill="hold">
-                                          <p:stCondLst>
-                                            <p:cond delay="0"/>
-                                          </p:stCondLst>
-                                        </p:cTn>
-                                        <p:tgtEl>
-                                          <p:spTgt spid="906"/>
-                                        </p:tgtEl>
-                                        <p:attrNameLst>
-                                          <p:attrName>style.visibility</p:attrName>
-                                        </p:attrNameLst>
-                                      </p:cBhvr>
-                                      <p:to>
-                                        <p:strVal val="visible"/>
-                                      </p:to>
-                                    </p:set>
-                                    <p:animEffect transition="in" filter="fade">
-                                      <p:cBhvr>
-                                        <p:cTn id="13" dur="500"/>
-                                        <p:tgtEl>
-                                          <p:spTgt spid="906"/>
-                                        </p:tgtEl>
-                                      </p:cBhvr>
-                                    </p:animEffect>
-                                  </p:childTnLst>
-                                </p:cTn>
-                              </p:par>
-                              <p:par>
-                                <p:cTn id="14" presetID="10" presetClass="entr" presetSubtype="0" fill="hold" grpId="0" nodeType="withEffect">
-                                  <p:stCondLst>
-                                    <p:cond delay="3200"/>
-                                  </p:stCondLst>
-                                  <p:childTnLst>
-                                    <p:set>
-                                      <p:cBhvr>
-                                        <p:cTn id="15" dur="1" fill="hold">
-                                          <p:stCondLst>
-                                            <p:cond delay="0"/>
-                                          </p:stCondLst>
-                                        </p:cTn>
-                                        <p:tgtEl>
-                                          <p:spTgt spid="907"/>
-                                        </p:tgtEl>
-                                        <p:attrNameLst>
-                                          <p:attrName>style.visibility</p:attrName>
-                                        </p:attrNameLst>
-                                      </p:cBhvr>
-                                      <p:to>
-                                        <p:strVal val="visible"/>
-                                      </p:to>
-                                    </p:set>
-                                    <p:animEffect transition="in" filter="fade">
-                                      <p:cBhvr>
-                                        <p:cTn id="16" dur="500"/>
-                                        <p:tgtEl>
-                                          <p:spTgt spid="907"/>
-                                        </p:tgtEl>
-                                      </p:cBhvr>
-                                    </p:animEffect>
-                                  </p:childTnLst>
-                                </p:cTn>
-                              </p:par>
-                            </p:childTnLst>
-                          </p:cTn>
-                        </p:par>
-                      </p:childTnLst>
-                    </p:cTn>
-                  </p:par>
-                </p:childTnLst>
-              </p:cTn>
-              <p:prevCondLst>
-                <p:cond evt="onPrev" delay="0">
-                  <p:tgtEl>
-                    <p:sldTgt/>
-                  </p:tgtEl>
-                </p:cond>
-              </p:prevCondLst>
-              <p:nextCondLst>
-                <p:cond evt="onNext" delay="0">
-                  <p:tgtEl>
-                    <p:sldTgt/>
-                  </p:tgtEl>
-                </p:cond>
-              </p:nextCondLst>
-            </p:seq>
-          </p:childTnLst>
-        </p:cTn>
-      </p:par>
-    </p:tnLst>
-    <p:bldLst>
-      <p:bldP spid="904" grpId="0" animBg="1"/>
-      <p:bldP spid="905" grpId="0" animBg="1"/>
-      <p:bldP spid="906" grpId="0" animBg="1"/>
-      <p:bldP spid="907" grpId="0" animBg="1"/>
-    </p:bldLst>
-  </p:timing>
 </p:sld>
 </file>
 
@@ -19980,314 +18997,6 @@
   <p:clrMapOvr>
     <a:masterClrMapping/>
   </p:clrMapOvr>
-  <p:transition spd="med">
-    <p:fade/>
-  </p:transition>
-  <p:timing>
-    <p:tnLst>
-      <p:par>
-        <p:cTn id="1" dur="indefinite" restart="never" nodeType="tmRoot">
-          <p:childTnLst>
-            <p:seq concurrent="1" nextAc="seek">
-              <p:cTn id="2" dur="indefinite" nodeType="mainSeq">
-                <p:childTnLst>
-                  <p:par>
-                    <p:cTn id="3" fill="hold">
-                      <p:stCondLst>
-                        <p:cond delay="indefinite"/>
-                        <p:cond evt="onBegin" delay="0">
-                          <p:tn val="2"/>
-                        </p:cond>
-                      </p:stCondLst>
-                      <p:childTnLst>
-                        <p:par>
-                          <p:cTn id="4" fill="hold">
-                            <p:stCondLst>
-                              <p:cond delay="0"/>
-                            </p:stCondLst>
-                            <p:childTnLst>
-                              <p:par>
-                                <p:cTn id="5" presetID="10" presetClass="entr" presetSubtype="0" fill="hold" grpId="0" nodeType="afterEffect">
-                                  <p:stCondLst>
-                                    <p:cond delay="300"/>
-                                  </p:stCondLst>
-                                  <p:childTnLst>
-                                    <p:set>
-                                      <p:cBhvr>
-                                        <p:cTn id="6" dur="1" fill="hold">
-                                          <p:stCondLst>
-                                            <p:cond delay="0"/>
-                                          </p:stCondLst>
-                                        </p:cTn>
-                                        <p:tgtEl>
-                                          <p:spTgt spid="903"/>
-                                        </p:tgtEl>
-                                        <p:attrNameLst>
-                                          <p:attrName>style.visibility</p:attrName>
-                                        </p:attrNameLst>
-                                      </p:cBhvr>
-                                      <p:to>
-                                        <p:strVal val="visible"/>
-                                      </p:to>
-                                    </p:set>
-                                    <p:animEffect transition="in" filter="fade">
-                                      <p:cBhvr>
-                                        <p:cTn id="7" dur="500"/>
-                                        <p:tgtEl>
-                                          <p:spTgt spid="903"/>
-                                        </p:tgtEl>
-                                      </p:cBhvr>
-                                    </p:animEffect>
-                                  </p:childTnLst>
-                                </p:cTn>
-                              </p:par>
-                              <p:par>
-                                <p:cTn id="8" presetID="10" presetClass="entr" presetSubtype="0" fill="hold" grpId="0" nodeType="withEffect">
-                                  <p:stCondLst>
-                                    <p:cond delay="300"/>
-                                  </p:stCondLst>
-                                  <p:childTnLst>
-                                    <p:set>
-                                      <p:cBhvr>
-                                        <p:cTn id="9" dur="1" fill="hold">
-                                          <p:stCondLst>
-                                            <p:cond delay="0"/>
-                                          </p:stCondLst>
-                                        </p:cTn>
-                                        <p:tgtEl>
-                                          <p:spTgt spid="904"/>
-                                        </p:tgtEl>
-                                        <p:attrNameLst>
-                                          <p:attrName>style.visibility</p:attrName>
-                                        </p:attrNameLst>
-                                      </p:cBhvr>
-                                      <p:to>
-                                        <p:strVal val="visible"/>
-                                      </p:to>
-                                    </p:set>
-                                    <p:animEffect transition="in" filter="fade">
-                                      <p:cBhvr>
-                                        <p:cTn id="10" dur="500"/>
-                                        <p:tgtEl>
-                                          <p:spTgt spid="904"/>
-                                        </p:tgtEl>
-                                      </p:cBhvr>
-                                    </p:animEffect>
-                                  </p:childTnLst>
-                                </p:cTn>
-                              </p:par>
-                              <p:par>
-                                <p:cTn id="11" presetID="10" presetClass="entr" presetSubtype="0" fill="hold" grpId="0" nodeType="withEffect">
-                                  <p:stCondLst>
-                                    <p:cond delay="1000"/>
-                                  </p:stCondLst>
-                                  <p:childTnLst>
-                                    <p:set>
-                                      <p:cBhvr>
-                                        <p:cTn id="12" dur="1" fill="hold">
-                                          <p:stCondLst>
-                                            <p:cond delay="0"/>
-                                          </p:stCondLst>
-                                        </p:cTn>
-                                        <p:tgtEl>
-                                          <p:spTgt spid="905"/>
-                                        </p:tgtEl>
-                                        <p:attrNameLst>
-                                          <p:attrName>style.visibility</p:attrName>
-                                        </p:attrNameLst>
-                                      </p:cBhvr>
-                                      <p:to>
-                                        <p:strVal val="visible"/>
-                                      </p:to>
-                                    </p:set>
-                                    <p:animEffect transition="in" filter="fade">
-                                      <p:cBhvr>
-                                        <p:cTn id="13" dur="500"/>
-                                        <p:tgtEl>
-                                          <p:spTgt spid="905"/>
-                                        </p:tgtEl>
-                                      </p:cBhvr>
-                                    </p:animEffect>
-                                  </p:childTnLst>
-                                </p:cTn>
-                              </p:par>
-                              <p:par>
-                                <p:cTn id="14" presetID="10" presetClass="entr" presetSubtype="0" fill="hold" grpId="0" nodeType="withEffect">
-                                  <p:stCondLst>
-                                    <p:cond delay="1000"/>
-                                  </p:stCondLst>
-                                  <p:childTnLst>
-                                    <p:set>
-                                      <p:cBhvr>
-                                        <p:cTn id="15" dur="1" fill="hold">
-                                          <p:stCondLst>
-                                            <p:cond delay="0"/>
-                                          </p:stCondLst>
-                                        </p:cTn>
-                                        <p:tgtEl>
-                                          <p:spTgt spid="906"/>
-                                        </p:tgtEl>
-                                        <p:attrNameLst>
-                                          <p:attrName>style.visibility</p:attrName>
-                                        </p:attrNameLst>
-                                      </p:cBhvr>
-                                      <p:to>
-                                        <p:strVal val="visible"/>
-                                      </p:to>
-                                    </p:set>
-                                    <p:animEffect transition="in" filter="fade">
-                                      <p:cBhvr>
-                                        <p:cTn id="16" dur="500"/>
-                                        <p:tgtEl>
-                                          <p:spTgt spid="906"/>
-                                        </p:tgtEl>
-                                      </p:cBhvr>
-                                    </p:animEffect>
-                                  </p:childTnLst>
-                                </p:cTn>
-                              </p:par>
-                              <p:par>
-                                <p:cTn id="17" presetID="10" presetClass="entr" presetSubtype="0" fill="hold" grpId="0" nodeType="withEffect">
-                                  <p:stCondLst>
-                                    <p:cond delay="1700"/>
-                                  </p:stCondLst>
-                                  <p:childTnLst>
-                                    <p:set>
-                                      <p:cBhvr>
-                                        <p:cTn id="18" dur="1" fill="hold">
-                                          <p:stCondLst>
-                                            <p:cond delay="0"/>
-                                          </p:stCondLst>
-                                        </p:cTn>
-                                        <p:tgtEl>
-                                          <p:spTgt spid="907"/>
-                                        </p:tgtEl>
-                                        <p:attrNameLst>
-                                          <p:attrName>style.visibility</p:attrName>
-                                        </p:attrNameLst>
-                                      </p:cBhvr>
-                                      <p:to>
-                                        <p:strVal val="visible"/>
-                                      </p:to>
-                                    </p:set>
-                                    <p:animEffect transition="in" filter="fade">
-                                      <p:cBhvr>
-                                        <p:cTn id="19" dur="500"/>
-                                        <p:tgtEl>
-                                          <p:spTgt spid="907"/>
-                                        </p:tgtEl>
-                                      </p:cBhvr>
-                                    </p:animEffect>
-                                  </p:childTnLst>
-                                </p:cTn>
-                              </p:par>
-                              <p:par>
-                                <p:cTn id="20" presetID="10" presetClass="entr" presetSubtype="0" fill="hold" grpId="0" nodeType="withEffect">
-                                  <p:stCondLst>
-                                    <p:cond delay="1700"/>
-                                  </p:stCondLst>
-                                  <p:childTnLst>
-                                    <p:set>
-                                      <p:cBhvr>
-                                        <p:cTn id="21" dur="1" fill="hold">
-                                          <p:stCondLst>
-                                            <p:cond delay="0"/>
-                                          </p:stCondLst>
-                                        </p:cTn>
-                                        <p:tgtEl>
-                                          <p:spTgt spid="908"/>
-                                        </p:tgtEl>
-                                        <p:attrNameLst>
-                                          <p:attrName>style.visibility</p:attrName>
-                                        </p:attrNameLst>
-                                      </p:cBhvr>
-                                      <p:to>
-                                        <p:strVal val="visible"/>
-                                      </p:to>
-                                    </p:set>
-                                    <p:animEffect transition="in" filter="fade">
-                                      <p:cBhvr>
-                                        <p:cTn id="22" dur="500"/>
-                                        <p:tgtEl>
-                                          <p:spTgt spid="908"/>
-                                        </p:tgtEl>
-                                      </p:cBhvr>
-                                    </p:animEffect>
-                                  </p:childTnLst>
-                                </p:cTn>
-                              </p:par>
-                              <p:par>
-                                <p:cTn id="23" presetID="10" presetClass="entr" presetSubtype="0" fill="hold" grpId="0" nodeType="withEffect">
-                                  <p:stCondLst>
-                                    <p:cond delay="2600"/>
-                                  </p:stCondLst>
-                                  <p:childTnLst>
-                                    <p:set>
-                                      <p:cBhvr>
-                                        <p:cTn id="24" dur="1" fill="hold">
-                                          <p:stCondLst>
-                                            <p:cond delay="0"/>
-                                          </p:stCondLst>
-                                        </p:cTn>
-                                        <p:tgtEl>
-                                          <p:spTgt spid="909"/>
-                                        </p:tgtEl>
-                                        <p:attrNameLst>
-                                          <p:attrName>style.visibility</p:attrName>
-                                        </p:attrNameLst>
-                                      </p:cBhvr>
-                                      <p:to>
-                                        <p:strVal val="visible"/>
-                                      </p:to>
-                                    </p:set>
-                                    <p:animEffect transition="in" filter="fade">
-                                      <p:cBhvr>
-                                        <p:cTn id="25" dur="500"/>
-                                        <p:tgtEl>
-                                          <p:spTgt spid="909"/>
-                                        </p:tgtEl>
-                                      </p:cBhvr>
-                                    </p:animEffect>
-                                  </p:childTnLst>
-                                </p:cTn>
-                              </p:par>
-                            </p:childTnLst>
-                          </p:cTn>
-                        </p:par>
-                      </p:childTnLst>
-                    </p:cTn>
-                  </p:par>
-                </p:childTnLst>
-              </p:cTn>
-              <p:prevCondLst>
-                <p:cond evt="onPrev" delay="0">
-                  <p:tgtEl>
-                    <p:sldTgt/>
-                  </p:tgtEl>
-                </p:cond>
-              </p:prevCondLst>
-              <p:nextCondLst>
-                <p:cond evt="onNext" delay="0">
-                  <p:tgtEl>
-                    <p:sldTgt/>
-                  </p:tgtEl>
-                </p:cond>
-              </p:nextCondLst>
-            </p:seq>
-          </p:childTnLst>
-        </p:cTn>
-      </p:par>
-    </p:tnLst>
-    <p:bldLst>
-      <p:bldP spid="903" grpId="0" animBg="1"/>
-      <p:bldP spid="904" grpId="0" animBg="1"/>
-      <p:bldP spid="905" grpId="0" animBg="1"/>
-      <p:bldP spid="906" grpId="0" animBg="1"/>
-      <p:bldP spid="907" grpId="0" animBg="1"/>
-      <p:bldP spid="908" grpId="0" animBg="1"/>
-      <p:bldP spid="909" grpId="0" animBg="1"/>
-    </p:bldLst>
-  </p:timing>
 </p:sld>
 </file>
 
@@ -20508,98 +19217,6 @@
   <p:clrMapOvr>
     <a:masterClrMapping/>
   </p:clrMapOvr>
-  <p:transition spd="med">
-    <p:fade/>
-  </p:transition>
-  <p:timing>
-    <p:tnLst>
-      <p:par>
-        <p:cTn id="1" dur="indefinite" restart="never" nodeType="tmRoot">
-          <p:childTnLst>
-            <p:seq concurrent="1" nextAc="seek">
-              <p:cTn id="2" dur="indefinite" nodeType="mainSeq">
-                <p:childTnLst>
-                  <p:par>
-                    <p:cTn id="3" fill="hold">
-                      <p:stCondLst>
-                        <p:cond delay="indefinite"/>
-                        <p:cond evt="onBegin" delay="0">
-                          <p:tn val="2"/>
-                        </p:cond>
-                      </p:stCondLst>
-                      <p:childTnLst>
-                        <p:par>
-                          <p:cTn id="4" fill="hold">
-                            <p:stCondLst>
-                              <p:cond delay="0"/>
-                            </p:stCondLst>
-                            <p:childTnLst>
-                              <p:par>
-                                <p:cTn id="5" presetID="10" presetClass="entr" presetSubtype="0" fill="hold" grpId="0" nodeType="afterEffect">
-                                  <p:stCondLst>
-                                    <p:cond delay="1300"/>
-                                  </p:stCondLst>
-                                  <p:childTnLst>
-                                    <p:set>
-                                      <p:cBhvr>
-                                        <p:cTn id="6" dur="1" fill="hold">
-                                          <p:stCondLst>
-                                            <p:cond delay="0"/>
-                                          </p:stCondLst>
-                                        </p:cTn>
-                                        <p:tgtEl>
-                                          <p:spTgt spid="3"/>
-                                        </p:tgtEl>
-                                        <p:attrNameLst>
-                                          <p:attrName>style.visibility</p:attrName>
-                                        </p:attrNameLst>
-                                      </p:cBhvr>
-                                      <p:to>
-                                        <p:strVal val="visible"/>
-                                      </p:to>
-                                    </p:set>
-                                    <p:animEffect transition="in" filter="fade">
-                                      <p:cBhvr>
-                                        <p:cTn id="7" dur="500"/>
-                                        <p:tgtEl>
-                                          <p:spTgt spid="3"/>
-                                        </p:tgtEl>
-                                      </p:cBhvr>
-                                    </p:animEffect>
-                                  </p:childTnLst>
-                                </p:cTn>
-                              </p:par>
-                            </p:childTnLst>
-                          </p:cTn>
-                        </p:par>
-                      </p:childTnLst>
-                    </p:cTn>
-                  </p:par>
-                </p:childTnLst>
-              </p:cTn>
-              <p:prevCondLst>
-                <p:cond evt="onPrev" delay="0">
-                  <p:tgtEl>
-                    <p:sldTgt/>
-                  </p:tgtEl>
-                </p:cond>
-              </p:prevCondLst>
-              <p:nextCondLst>
-                <p:cond evt="onNext" delay="0">
-                  <p:tgtEl>
-                    <p:sldTgt/>
-                  </p:tgtEl>
-                </p:cond>
-              </p:nextCondLst>
-            </p:seq>
-          </p:childTnLst>
-        </p:cTn>
-      </p:par>
-    </p:tnLst>
-    <p:bldLst>
-      <p:bldP spid="3" grpId="0" animBg="1"/>
-    </p:bldLst>
-  </p:timing>
 </p:sld>
 </file>
 

</xml_diff>

<commit_message>
Pitch deck (static): drop challenge-owner label on slide 3, slide tweaks
Merges local edits to slides 1-4 and 6-9 with the appendix slides
added upstream.

Co-Authored-By: Claude Opus 5.5 <noreply@anthropic.com>
</commit_message>
<xml_diff>
--- a/research/Mutz_Pitch_lean_static.pptx
+++ b/research/Mutz_Pitch_lean_static.pptx
@@ -7278,6 +7278,137 @@
   <p:clrMapOvr>
     <a:masterClrMapping/>
   </p:clrMapOvr>
+  <p:timing>
+    <p:tnLst>
+      <p:par>
+        <p:cTn id="1" dur="indefinite" restart="never" nodeType="tmRoot">
+          <p:childTnLst>
+            <p:seq concurrent="1" nextAc="seek">
+              <p:cTn id="2" dur="indefinite" nodeType="mainSeq">
+                <p:childTnLst>
+                  <p:par>
+                    <p:cTn id="3" fill="hold">
+                      <p:stCondLst>
+                        <p:cond delay="indefinite"/>
+                      </p:stCondLst>
+                      <p:childTnLst>
+                        <p:par>
+                          <p:cTn id="4" fill="hold">
+                            <p:stCondLst>
+                              <p:cond delay="0"/>
+                            </p:stCondLst>
+                            <p:childTnLst>
+                              <p:par>
+                                <p:cTn id="5" presetID="1" presetClass="entr" presetSubtype="0" fill="hold" grpId="0" nodeType="clickEffect">
+                                  <p:stCondLst>
+                                    <p:cond delay="0"/>
+                                  </p:stCondLst>
+                                  <p:childTnLst>
+                                    <p:set>
+                                      <p:cBhvr>
+                                        <p:cTn id="6" dur="1" fill="hold">
+                                          <p:stCondLst>
+                                            <p:cond delay="0"/>
+                                          </p:stCondLst>
+                                        </p:cTn>
+                                        <p:tgtEl>
+                                          <p:spTgt spid="3">
+                                            <p:txEl>
+                                              <p:pRg st="0" end="0"/>
+                                            </p:txEl>
+                                          </p:spTgt>
+                                        </p:tgtEl>
+                                        <p:attrNameLst>
+                                          <p:attrName>style.visibility</p:attrName>
+                                        </p:attrNameLst>
+                                      </p:cBhvr>
+                                      <p:to>
+                                        <p:strVal val="visible"/>
+                                      </p:to>
+                                    </p:set>
+                                  </p:childTnLst>
+                                </p:cTn>
+                              </p:par>
+                            </p:childTnLst>
+                          </p:cTn>
+                        </p:par>
+                      </p:childTnLst>
+                    </p:cTn>
+                  </p:par>
+                  <p:par>
+                    <p:cTn id="7" fill="hold">
+                      <p:stCondLst>
+                        <p:cond delay="indefinite"/>
+                      </p:stCondLst>
+                      <p:childTnLst>
+                        <p:par>
+                          <p:cTn id="8" fill="hold">
+                            <p:stCondLst>
+                              <p:cond delay="0"/>
+                            </p:stCondLst>
+                            <p:childTnLst>
+                              <p:par>
+                                <p:cTn id="9" presetID="1" presetClass="entr" presetSubtype="0" fill="hold" grpId="0" nodeType="clickEffect">
+                                  <p:stCondLst>
+                                    <p:cond delay="0"/>
+                                  </p:stCondLst>
+                                  <p:childTnLst>
+                                    <p:set>
+                                      <p:cBhvr>
+                                        <p:cTn id="10" dur="1" fill="hold">
+                                          <p:stCondLst>
+                                            <p:cond delay="0"/>
+                                          </p:stCondLst>
+                                        </p:cTn>
+                                        <p:tgtEl>
+                                          <p:spTgt spid="3">
+                                            <p:txEl>
+                                              <p:pRg st="1" end="1"/>
+                                            </p:txEl>
+                                          </p:spTgt>
+                                        </p:tgtEl>
+                                        <p:attrNameLst>
+                                          <p:attrName>style.visibility</p:attrName>
+                                        </p:attrNameLst>
+                                      </p:cBhvr>
+                                      <p:to>
+                                        <p:strVal val="visible"/>
+                                      </p:to>
+                                    </p:set>
+                                  </p:childTnLst>
+                                </p:cTn>
+                              </p:par>
+                            </p:childTnLst>
+                          </p:cTn>
+                        </p:par>
+                      </p:childTnLst>
+                    </p:cTn>
+                  </p:par>
+                </p:childTnLst>
+              </p:cTn>
+              <p:prevCondLst>
+                <p:cond evt="onPrev" delay="0">
+                  <p:tgtEl>
+                    <p:sldTgt/>
+                  </p:tgtEl>
+                </p:cond>
+              </p:prevCondLst>
+              <p:nextCondLst>
+                <p:cond evt="onNext" delay="0">
+                  <p:tgtEl>
+                    <p:sldTgt/>
+                  </p:tgtEl>
+                </p:cond>
+              </p:nextCondLst>
+            </p:seq>
+          </p:childTnLst>
+        </p:cTn>
+      </p:par>
+    </p:tnLst>
+    <p:bldLst>
+      <p:bldP spid="3" grpId="0" build="p"/>
+    </p:bldLst>
+  </p:timing>
 </p:sld>
 </file>
 
@@ -16749,6 +16880,130 @@
   <p:clrMapOvr>
     <a:masterClrMapping/>
   </p:clrMapOvr>
+  <p:timing>
+    <p:tnLst>
+      <p:par>
+        <p:cTn id="1" dur="indefinite" restart="never" nodeType="tmRoot">
+          <p:childTnLst>
+            <p:seq concurrent="1" nextAc="seek">
+              <p:cTn id="2" dur="indefinite" nodeType="mainSeq">
+                <p:childTnLst>
+                  <p:par>
+                    <p:cTn id="3" fill="hold">
+                      <p:stCondLst>
+                        <p:cond delay="indefinite"/>
+                      </p:stCondLst>
+                      <p:childTnLst>
+                        <p:par>
+                          <p:cTn id="4" fill="hold">
+                            <p:stCondLst>
+                              <p:cond delay="0"/>
+                            </p:stCondLst>
+                            <p:childTnLst>
+                              <p:par>
+                                <p:cTn id="5" presetID="1" presetClass="entr" presetSubtype="0" fill="hold" grpId="0" nodeType="clickEffect">
+                                  <p:stCondLst>
+                                    <p:cond delay="0"/>
+                                  </p:stCondLst>
+                                  <p:childTnLst>
+                                    <p:set>
+                                      <p:cBhvr>
+                                        <p:cTn id="6" dur="1" fill="hold">
+                                          <p:stCondLst>
+                                            <p:cond delay="0"/>
+                                          </p:stCondLst>
+                                        </p:cTn>
+                                        <p:tgtEl>
+                                          <p:spTgt spid="904"/>
+                                        </p:tgtEl>
+                                        <p:attrNameLst>
+                                          <p:attrName>style.visibility</p:attrName>
+                                        </p:attrNameLst>
+                                      </p:cBhvr>
+                                      <p:to>
+                                        <p:strVal val="visible"/>
+                                      </p:to>
+                                    </p:set>
+                                  </p:childTnLst>
+                                </p:cTn>
+                              </p:par>
+                            </p:childTnLst>
+                          </p:cTn>
+                        </p:par>
+                      </p:childTnLst>
+                    </p:cTn>
+                  </p:par>
+                  <p:par>
+                    <p:cTn id="7" fill="hold">
+                      <p:stCondLst>
+                        <p:cond delay="indefinite"/>
+                      </p:stCondLst>
+                      <p:childTnLst>
+                        <p:par>
+                          <p:cTn id="8" fill="hold">
+                            <p:stCondLst>
+                              <p:cond delay="0"/>
+                            </p:stCondLst>
+                            <p:childTnLst>
+                              <p:par>
+                                <p:cTn id="9" presetID="1" presetClass="entr" presetSubtype="0" fill="hold" grpId="0" nodeType="clickEffect">
+                                  <p:stCondLst>
+                                    <p:cond delay="0"/>
+                                  </p:stCondLst>
+                                  <p:childTnLst>
+                                    <p:set>
+                                      <p:cBhvr>
+                                        <p:cTn id="10" dur="1" fill="hold">
+                                          <p:stCondLst>
+                                            <p:cond delay="0"/>
+                                          </p:stCondLst>
+                                        </p:cTn>
+                                        <p:tgtEl>
+                                          <p:spTgt spid="905"/>
+                                        </p:tgtEl>
+                                        <p:attrNameLst>
+                                          <p:attrName>style.visibility</p:attrName>
+                                        </p:attrNameLst>
+                                      </p:cBhvr>
+                                      <p:to>
+                                        <p:strVal val="visible"/>
+                                      </p:to>
+                                    </p:set>
+                                  </p:childTnLst>
+                                </p:cTn>
+                              </p:par>
+                            </p:childTnLst>
+                          </p:cTn>
+                        </p:par>
+                      </p:childTnLst>
+                    </p:cTn>
+                  </p:par>
+                </p:childTnLst>
+              </p:cTn>
+              <p:prevCondLst>
+                <p:cond evt="onPrev" delay="0">
+                  <p:tgtEl>
+                    <p:sldTgt/>
+                  </p:tgtEl>
+                </p:cond>
+              </p:prevCondLst>
+              <p:nextCondLst>
+                <p:cond evt="onNext" delay="0">
+                  <p:tgtEl>
+                    <p:sldTgt/>
+                  </p:tgtEl>
+                </p:cond>
+              </p:nextCondLst>
+            </p:seq>
+          </p:childTnLst>
+        </p:cTn>
+      </p:par>
+    </p:tnLst>
+    <p:bldLst>
+      <p:bldP spid="904" grpId="0" animBg="1"/>
+      <p:bldP spid="905" grpId="0" animBg="1"/>
+    </p:bldLst>
+  </p:timing>
 </p:sld>
 </file>
 
@@ -19815,68 +20070,6 @@
       </p:pic>
       <p:sp>
         <p:nvSpPr>
-          <p:cNvPr id="908" name="Challenge owner label"/>
-          <p:cNvSpPr txBox="1"/>
-          <p:nvPr/>
-        </p:nvSpPr>
-        <p:spPr>
-          <a:xfrm>
-            <a:off x="7318988" y="5930302"/>
-            <a:ext cx="1371600" cy="152400"/>
-          </a:xfrm>
-          <a:prstGeom prst="rect">
-            <a:avLst/>
-          </a:prstGeom>
-          <a:noFill/>
-        </p:spPr>
-        <p:txBody>
-          <a:bodyPr wrap="square" lIns="0" rIns="0" tIns="0" bIns="0" anchor="t">
-            <a:spAutoFit/>
-          </a:bodyPr>
-          <a:lstStyle/>
-          <a:p>
-            <a:pPr algn="r">
-              <a:spcAft>
-                <a:spcPts val="0"/>
-              </a:spcAft>
-            </a:pPr>
-            <a:r>
-              <a:rPr lang="en-GB" sz="1000" b="0" i="0">
-                <a:solidFill>
-                  <a:srgbClr val="63737B"/>
-                </a:solidFill>
-              </a:rPr>
-              <a:t>Challenge owner</a:t>
-            </a:r>
-          </a:p>
-        </p:txBody>
-      </p:sp>
-      <p:pic>
-        <p:nvPicPr>
-          <p:cNvPr id="909" name="Bern Economic Development Agency logo" descr="Bern Economic Development Agency"/>
-          <p:cNvPicPr>
-            <a:picLocks noChangeAspect="1"/>
-          </p:cNvPicPr>
-          <p:nvPr/>
-        </p:nvPicPr>
-        <p:blipFill>
-          <a:blip r:embed="rId91"/>
-          <a:stretch>
-            <a:fillRect/>
-          </a:stretch>
-        </p:blipFill>
-        <p:spPr>
-          <a:xfrm>
-            <a:off x="8800316" y="5577840"/>
-            <a:ext cx="1566717" cy="502920"/>
-          </a:xfrm>
-          <a:prstGeom prst="rect">
-            <a:avLst/>
-          </a:prstGeom>
-        </p:spPr>
-      </p:pic>
-      <p:sp>
-        <p:nvSpPr>
           <p:cNvPr id="902" name="Foliennummernplatzhalter 5">
             <a:extLst>
               <a:ext uri="{FF2B5EF4-FFF2-40B4-BE49-F238E27FC236}">
@@ -19910,6 +20103,112 @@
   <p:clrMapOvr>
     <a:masterClrMapping/>
   </p:clrMapOvr>
+  <p:timing>
+    <p:tnLst>
+      <p:par>
+        <p:cTn id="1" dur="indefinite" restart="never" nodeType="tmRoot">
+          <p:childTnLst>
+            <p:seq concurrent="1" nextAc="seek">
+              <p:cTn id="2" dur="indefinite" nodeType="mainSeq">
+                <p:childTnLst>
+                  <p:par>
+                    <p:cTn id="3" fill="hold">
+                      <p:stCondLst>
+                        <p:cond delay="indefinite"/>
+                      </p:stCondLst>
+                      <p:childTnLst>
+                        <p:par>
+                          <p:cTn id="4" fill="hold">
+                            <p:stCondLst>
+                              <p:cond delay="0"/>
+                            </p:stCondLst>
+                            <p:childTnLst>
+                              <p:par>
+                                <p:cTn id="5" presetID="1" presetClass="entr" presetSubtype="0" fill="hold" grpId="0" nodeType="clickEffect">
+                                  <p:stCondLst>
+                                    <p:cond delay="0"/>
+                                  </p:stCondLst>
+                                  <p:childTnLst>
+                                    <p:set>
+                                      <p:cBhvr>
+                                        <p:cTn id="6" dur="1" fill="hold">
+                                          <p:stCondLst>
+                                            <p:cond delay="0"/>
+                                          </p:stCondLst>
+                                        </p:cTn>
+                                        <p:tgtEl>
+                                          <p:spTgt spid="904"/>
+                                        </p:tgtEl>
+                                        <p:attrNameLst>
+                                          <p:attrName>style.visibility</p:attrName>
+                                        </p:attrNameLst>
+                                      </p:cBhvr>
+                                      <p:to>
+                                        <p:strVal val="visible"/>
+                                      </p:to>
+                                    </p:set>
+                                  </p:childTnLst>
+                                </p:cTn>
+                              </p:par>
+                              <p:par>
+                                <p:cTn id="7" presetID="1" presetClass="entr" presetSubtype="0" fill="hold" grpId="0" nodeType="withEffect">
+                                  <p:stCondLst>
+                                    <p:cond delay="0"/>
+                                  </p:stCondLst>
+                                  <p:childTnLst>
+                                    <p:set>
+                                      <p:cBhvr>
+                                        <p:cTn id="8" dur="1" fill="hold">
+                                          <p:stCondLst>
+                                            <p:cond delay="0"/>
+                                          </p:stCondLst>
+                                        </p:cTn>
+                                        <p:tgtEl>
+                                          <p:spTgt spid="905"/>
+                                        </p:tgtEl>
+                                        <p:attrNameLst>
+                                          <p:attrName>style.visibility</p:attrName>
+                                        </p:attrNameLst>
+                                      </p:cBhvr>
+                                      <p:to>
+                                        <p:strVal val="visible"/>
+                                      </p:to>
+                                    </p:set>
+                                  </p:childTnLst>
+                                </p:cTn>
+                              </p:par>
+                            </p:childTnLst>
+                          </p:cTn>
+                        </p:par>
+                      </p:childTnLst>
+                    </p:cTn>
+                  </p:par>
+                </p:childTnLst>
+              </p:cTn>
+              <p:prevCondLst>
+                <p:cond evt="onPrev" delay="0">
+                  <p:tgtEl>
+                    <p:sldTgt/>
+                  </p:tgtEl>
+                </p:cond>
+              </p:prevCondLst>
+              <p:nextCondLst>
+                <p:cond evt="onNext" delay="0">
+                  <p:tgtEl>
+                    <p:sldTgt/>
+                  </p:tgtEl>
+                </p:cond>
+              </p:nextCondLst>
+            </p:seq>
+          </p:childTnLst>
+        </p:cTn>
+      </p:par>
+    </p:tnLst>
+    <p:bldLst>
+      <p:bldP spid="904" grpId="0" animBg="1"/>
+      <p:bldP spid="905" grpId="0" animBg="1"/>
+    </p:bldLst>
+  </p:timing>
 </p:sld>
 </file>
 
@@ -20125,6 +20424,84 @@
   <p:clrMapOvr>
     <a:masterClrMapping/>
   </p:clrMapOvr>
+  <p:timing>
+    <p:tnLst>
+      <p:par>
+        <p:cTn id="1" dur="indefinite" restart="never" nodeType="tmRoot">
+          <p:childTnLst>
+            <p:seq concurrent="1" nextAc="seek">
+              <p:cTn id="2" dur="indefinite" nodeType="mainSeq">
+                <p:childTnLst>
+                  <p:par>
+                    <p:cTn id="3" fill="hold">
+                      <p:stCondLst>
+                        <p:cond delay="indefinite"/>
+                      </p:stCondLst>
+                      <p:childTnLst>
+                        <p:par>
+                          <p:cTn id="4" fill="hold">
+                            <p:stCondLst>
+                              <p:cond delay="0"/>
+                            </p:stCondLst>
+                            <p:childTnLst>
+                              <p:par>
+                                <p:cTn id="5" presetID="1" presetClass="entr" presetSubtype="0" fill="hold" grpId="0" nodeType="clickEffect">
+                                  <p:stCondLst>
+                                    <p:cond delay="0"/>
+                                  </p:stCondLst>
+                                  <p:childTnLst>
+                                    <p:set>
+                                      <p:cBhvr>
+                                        <p:cTn id="6" dur="1" fill="hold">
+                                          <p:stCondLst>
+                                            <p:cond delay="0"/>
+                                          </p:stCondLst>
+                                        </p:cTn>
+                                        <p:tgtEl>
+                                          <p:spTgt spid="905"/>
+                                        </p:tgtEl>
+                                        <p:attrNameLst>
+                                          <p:attrName>style.visibility</p:attrName>
+                                        </p:attrNameLst>
+                                      </p:cBhvr>
+                                      <p:to>
+                                        <p:strVal val="visible"/>
+                                      </p:to>
+                                    </p:set>
+                                  </p:childTnLst>
+                                </p:cTn>
+                              </p:par>
+                            </p:childTnLst>
+                          </p:cTn>
+                        </p:par>
+                      </p:childTnLst>
+                    </p:cTn>
+                  </p:par>
+                </p:childTnLst>
+              </p:cTn>
+              <p:prevCondLst>
+                <p:cond evt="onPrev" delay="0">
+                  <p:tgtEl>
+                    <p:sldTgt/>
+                  </p:tgtEl>
+                </p:cond>
+              </p:prevCondLst>
+              <p:nextCondLst>
+                <p:cond evt="onNext" delay="0">
+                  <p:tgtEl>
+                    <p:sldTgt/>
+                  </p:tgtEl>
+                </p:cond>
+              </p:nextCondLst>
+            </p:seq>
+          </p:childTnLst>
+        </p:cTn>
+      </p:par>
+    </p:tnLst>
+    <p:bldLst>
+      <p:bldP spid="905" grpId="0" animBg="1"/>
+    </p:bldLst>
+  </p:timing>
 </p:sld>
 </file>
 
@@ -20673,6 +21050,314 @@
   <p:clrMapOvr>
     <a:masterClrMapping/>
   </p:clrMapOvr>
+  <p:timing>
+    <p:tnLst>
+      <p:par>
+        <p:cTn id="1" dur="indefinite" restart="never" nodeType="tmRoot">
+          <p:childTnLst>
+            <p:seq concurrent="1" nextAc="seek">
+              <p:cTn id="2" dur="indefinite" nodeType="mainSeq">
+                <p:childTnLst>
+                  <p:par>
+                    <p:cTn id="3" fill="hold">
+                      <p:stCondLst>
+                        <p:cond delay="indefinite"/>
+                      </p:stCondLst>
+                      <p:childTnLst>
+                        <p:par>
+                          <p:cTn id="4" fill="hold">
+                            <p:stCondLst>
+                              <p:cond delay="0"/>
+                            </p:stCondLst>
+                            <p:childTnLst>
+                              <p:par>
+                                <p:cTn id="5" presetID="1" presetClass="entr" presetSubtype="0" fill="hold" grpId="0" nodeType="clickEffect">
+                                  <p:stCondLst>
+                                    <p:cond delay="0"/>
+                                  </p:stCondLst>
+                                  <p:childTnLst>
+                                    <p:set>
+                                      <p:cBhvr>
+                                        <p:cTn id="6" dur="1" fill="hold">
+                                          <p:stCondLst>
+                                            <p:cond delay="0"/>
+                                          </p:stCondLst>
+                                        </p:cTn>
+                                        <p:tgtEl>
+                                          <p:spTgt spid="908"/>
+                                        </p:tgtEl>
+                                        <p:attrNameLst>
+                                          <p:attrName>style.visibility</p:attrName>
+                                        </p:attrNameLst>
+                                      </p:cBhvr>
+                                      <p:to>
+                                        <p:strVal val="visible"/>
+                                      </p:to>
+                                    </p:set>
+                                  </p:childTnLst>
+                                </p:cTn>
+                              </p:par>
+                              <p:par>
+                                <p:cTn id="7" presetID="1" presetClass="entr" presetSubtype="0" fill="hold" grpId="0" nodeType="withEffect">
+                                  <p:stCondLst>
+                                    <p:cond delay="0"/>
+                                  </p:stCondLst>
+                                  <p:childTnLst>
+                                    <p:set>
+                                      <p:cBhvr>
+                                        <p:cTn id="8" dur="1" fill="hold">
+                                          <p:stCondLst>
+                                            <p:cond delay="0"/>
+                                          </p:stCondLst>
+                                        </p:cTn>
+                                        <p:tgtEl>
+                                          <p:spTgt spid="909"/>
+                                        </p:tgtEl>
+                                        <p:attrNameLst>
+                                          <p:attrName>style.visibility</p:attrName>
+                                        </p:attrNameLst>
+                                      </p:cBhvr>
+                                      <p:to>
+                                        <p:strVal val="visible"/>
+                                      </p:to>
+                                    </p:set>
+                                  </p:childTnLst>
+                                </p:cTn>
+                              </p:par>
+                              <p:par>
+                                <p:cTn id="9" presetID="1" presetClass="entr" presetSubtype="0" fill="hold" grpId="0" nodeType="withEffect">
+                                  <p:stCondLst>
+                                    <p:cond delay="0"/>
+                                  </p:stCondLst>
+                                  <p:childTnLst>
+                                    <p:set>
+                                      <p:cBhvr>
+                                        <p:cTn id="10" dur="1" fill="hold">
+                                          <p:stCondLst>
+                                            <p:cond delay="0"/>
+                                          </p:stCondLst>
+                                        </p:cTn>
+                                        <p:tgtEl>
+                                          <p:spTgt spid="910"/>
+                                        </p:tgtEl>
+                                        <p:attrNameLst>
+                                          <p:attrName>style.visibility</p:attrName>
+                                        </p:attrNameLst>
+                                      </p:cBhvr>
+                                      <p:to>
+                                        <p:strVal val="visible"/>
+                                      </p:to>
+                                    </p:set>
+                                  </p:childTnLst>
+                                </p:cTn>
+                              </p:par>
+                              <p:par>
+                                <p:cTn id="11" presetID="1" presetClass="entr" presetSubtype="0" fill="hold" grpId="0" nodeType="withEffect">
+                                  <p:stCondLst>
+                                    <p:cond delay="0"/>
+                                  </p:stCondLst>
+                                  <p:childTnLst>
+                                    <p:set>
+                                      <p:cBhvr>
+                                        <p:cTn id="12" dur="1" fill="hold">
+                                          <p:stCondLst>
+                                            <p:cond delay="0"/>
+                                          </p:stCondLst>
+                                        </p:cTn>
+                                        <p:tgtEl>
+                                          <p:spTgt spid="911"/>
+                                        </p:tgtEl>
+                                        <p:attrNameLst>
+                                          <p:attrName>style.visibility</p:attrName>
+                                        </p:attrNameLst>
+                                      </p:cBhvr>
+                                      <p:to>
+                                        <p:strVal val="visible"/>
+                                      </p:to>
+                                    </p:set>
+                                  </p:childTnLst>
+                                </p:cTn>
+                              </p:par>
+                            </p:childTnLst>
+                          </p:cTn>
+                        </p:par>
+                      </p:childTnLst>
+                    </p:cTn>
+                  </p:par>
+                  <p:par>
+                    <p:cTn id="13" fill="hold">
+                      <p:stCondLst>
+                        <p:cond delay="indefinite"/>
+                      </p:stCondLst>
+                      <p:childTnLst>
+                        <p:par>
+                          <p:cTn id="14" fill="hold">
+                            <p:stCondLst>
+                              <p:cond delay="0"/>
+                            </p:stCondLst>
+                            <p:childTnLst>
+                              <p:par>
+                                <p:cTn id="15" presetID="1" presetClass="entr" presetSubtype="0" fill="hold" grpId="0" nodeType="clickEffect">
+                                  <p:stCondLst>
+                                    <p:cond delay="0"/>
+                                  </p:stCondLst>
+                                  <p:childTnLst>
+                                    <p:set>
+                                      <p:cBhvr>
+                                        <p:cTn id="16" dur="1" fill="hold">
+                                          <p:stCondLst>
+                                            <p:cond delay="0"/>
+                                          </p:stCondLst>
+                                        </p:cTn>
+                                        <p:tgtEl>
+                                          <p:spTgt spid="904"/>
+                                        </p:tgtEl>
+                                        <p:attrNameLst>
+                                          <p:attrName>style.visibility</p:attrName>
+                                        </p:attrNameLst>
+                                      </p:cBhvr>
+                                      <p:to>
+                                        <p:strVal val="visible"/>
+                                      </p:to>
+                                    </p:set>
+                                  </p:childTnLst>
+                                </p:cTn>
+                              </p:par>
+                              <p:par>
+                                <p:cTn id="17" presetID="1" presetClass="entr" presetSubtype="0" fill="hold" grpId="0" nodeType="withEffect">
+                                  <p:stCondLst>
+                                    <p:cond delay="0"/>
+                                  </p:stCondLst>
+                                  <p:childTnLst>
+                                    <p:set>
+                                      <p:cBhvr>
+                                        <p:cTn id="18" dur="1" fill="hold">
+                                          <p:stCondLst>
+                                            <p:cond delay="0"/>
+                                          </p:stCondLst>
+                                        </p:cTn>
+                                        <p:tgtEl>
+                                          <p:spTgt spid="905"/>
+                                        </p:tgtEl>
+                                        <p:attrNameLst>
+                                          <p:attrName>style.visibility</p:attrName>
+                                        </p:attrNameLst>
+                                      </p:cBhvr>
+                                      <p:to>
+                                        <p:strVal val="visible"/>
+                                      </p:to>
+                                    </p:set>
+                                  </p:childTnLst>
+                                </p:cTn>
+                              </p:par>
+                              <p:par>
+                                <p:cTn id="19" presetID="1" presetClass="entr" presetSubtype="0" fill="hold" grpId="0" nodeType="withEffect">
+                                  <p:stCondLst>
+                                    <p:cond delay="0"/>
+                                  </p:stCondLst>
+                                  <p:childTnLst>
+                                    <p:set>
+                                      <p:cBhvr>
+                                        <p:cTn id="20" dur="1" fill="hold">
+                                          <p:stCondLst>
+                                            <p:cond delay="0"/>
+                                          </p:stCondLst>
+                                        </p:cTn>
+                                        <p:tgtEl>
+                                          <p:spTgt spid="906"/>
+                                        </p:tgtEl>
+                                        <p:attrNameLst>
+                                          <p:attrName>style.visibility</p:attrName>
+                                        </p:attrNameLst>
+                                      </p:cBhvr>
+                                      <p:to>
+                                        <p:strVal val="visible"/>
+                                      </p:to>
+                                    </p:set>
+                                  </p:childTnLst>
+                                </p:cTn>
+                              </p:par>
+                            </p:childTnLst>
+                          </p:cTn>
+                        </p:par>
+                      </p:childTnLst>
+                    </p:cTn>
+                  </p:par>
+                  <p:par>
+                    <p:cTn id="21" fill="hold">
+                      <p:stCondLst>
+                        <p:cond delay="indefinite"/>
+                      </p:stCondLst>
+                      <p:childTnLst>
+                        <p:par>
+                          <p:cTn id="22" fill="hold">
+                            <p:stCondLst>
+                              <p:cond delay="0"/>
+                            </p:stCondLst>
+                            <p:childTnLst>
+                              <p:par>
+                                <p:cTn id="23" presetID="1" presetClass="entr" presetSubtype="0" fill="hold" grpId="0" nodeType="clickEffect">
+                                  <p:stCondLst>
+                                    <p:cond delay="0"/>
+                                  </p:stCondLst>
+                                  <p:childTnLst>
+                                    <p:set>
+                                      <p:cBhvr>
+                                        <p:cTn id="24" dur="1" fill="hold">
+                                          <p:stCondLst>
+                                            <p:cond delay="0"/>
+                                          </p:stCondLst>
+                                        </p:cTn>
+                                        <p:tgtEl>
+                                          <p:spTgt spid="907"/>
+                                        </p:tgtEl>
+                                        <p:attrNameLst>
+                                          <p:attrName>style.visibility</p:attrName>
+                                        </p:attrNameLst>
+                                      </p:cBhvr>
+                                      <p:to>
+                                        <p:strVal val="visible"/>
+                                      </p:to>
+                                    </p:set>
+                                  </p:childTnLst>
+                                </p:cTn>
+                              </p:par>
+                            </p:childTnLst>
+                          </p:cTn>
+                        </p:par>
+                      </p:childTnLst>
+                    </p:cTn>
+                  </p:par>
+                </p:childTnLst>
+              </p:cTn>
+              <p:prevCondLst>
+                <p:cond evt="onPrev" delay="0">
+                  <p:tgtEl>
+                    <p:sldTgt/>
+                  </p:tgtEl>
+                </p:cond>
+              </p:prevCondLst>
+              <p:nextCondLst>
+                <p:cond evt="onNext" delay="0">
+                  <p:tgtEl>
+                    <p:sldTgt/>
+                  </p:tgtEl>
+                </p:cond>
+              </p:nextCondLst>
+            </p:seq>
+          </p:childTnLst>
+        </p:cTn>
+      </p:par>
+    </p:tnLst>
+    <p:bldLst>
+      <p:bldP spid="908" grpId="0" animBg="1"/>
+      <p:bldP spid="910" grpId="0" animBg="1"/>
+      <p:bldP spid="904" grpId="0" animBg="1"/>
+      <p:bldP spid="905" grpId="0" animBg="1"/>
+      <p:bldP spid="906" grpId="0" animBg="1"/>
+      <p:bldP spid="907" grpId="0" animBg="1"/>
+    </p:bldLst>
+  </p:timing>
 </p:sld>
 </file>
 
@@ -20947,6 +21632,186 @@
   <p:clrMapOvr>
     <a:masterClrMapping/>
   </p:clrMapOvr>
+  <p:timing>
+    <p:tnLst>
+      <p:par>
+        <p:cTn id="1" dur="indefinite" restart="never" nodeType="tmRoot">
+          <p:childTnLst>
+            <p:seq concurrent="1" nextAc="seek">
+              <p:cTn id="2" dur="indefinite" nodeType="mainSeq">
+                <p:childTnLst>
+                  <p:par>
+                    <p:cTn id="3" fill="hold">
+                      <p:stCondLst>
+                        <p:cond delay="indefinite"/>
+                      </p:stCondLst>
+                      <p:childTnLst>
+                        <p:par>
+                          <p:cTn id="4" fill="hold">
+                            <p:stCondLst>
+                              <p:cond delay="0"/>
+                            </p:stCondLst>
+                            <p:childTnLst>
+                              <p:par>
+                                <p:cTn id="5" presetID="1" presetClass="entr" presetSubtype="0" fill="hold" grpId="0" nodeType="clickEffect">
+                                  <p:stCondLst>
+                                    <p:cond delay="0"/>
+                                  </p:stCondLst>
+                                  <p:childTnLst>
+                                    <p:set>
+                                      <p:cBhvr>
+                                        <p:cTn id="6" dur="1" fill="hold">
+                                          <p:stCondLst>
+                                            <p:cond delay="0"/>
+                                          </p:stCondLst>
+                                        </p:cTn>
+                                        <p:tgtEl>
+                                          <p:spTgt spid="904"/>
+                                        </p:tgtEl>
+                                        <p:attrNameLst>
+                                          <p:attrName>style.visibility</p:attrName>
+                                        </p:attrNameLst>
+                                      </p:cBhvr>
+                                      <p:to>
+                                        <p:strVal val="visible"/>
+                                      </p:to>
+                                    </p:set>
+                                  </p:childTnLst>
+                                </p:cTn>
+                              </p:par>
+                              <p:par>
+                                <p:cTn id="7" presetID="1" presetClass="entr" presetSubtype="0" fill="hold" grpId="0" nodeType="withEffect">
+                                  <p:stCondLst>
+                                    <p:cond delay="0"/>
+                                  </p:stCondLst>
+                                  <p:childTnLst>
+                                    <p:set>
+                                      <p:cBhvr>
+                                        <p:cTn id="8" dur="1" fill="hold">
+                                          <p:stCondLst>
+                                            <p:cond delay="0"/>
+                                          </p:stCondLst>
+                                        </p:cTn>
+                                        <p:tgtEl>
+                                          <p:spTgt spid="905"/>
+                                        </p:tgtEl>
+                                        <p:attrNameLst>
+                                          <p:attrName>style.visibility</p:attrName>
+                                        </p:attrNameLst>
+                                      </p:cBhvr>
+                                      <p:to>
+                                        <p:strVal val="visible"/>
+                                      </p:to>
+                                    </p:set>
+                                  </p:childTnLst>
+                                </p:cTn>
+                              </p:par>
+                            </p:childTnLst>
+                          </p:cTn>
+                        </p:par>
+                      </p:childTnLst>
+                    </p:cTn>
+                  </p:par>
+                  <p:par>
+                    <p:cTn id="9" fill="hold">
+                      <p:stCondLst>
+                        <p:cond delay="indefinite"/>
+                      </p:stCondLst>
+                      <p:childTnLst>
+                        <p:par>
+                          <p:cTn id="10" fill="hold">
+                            <p:stCondLst>
+                              <p:cond delay="0"/>
+                            </p:stCondLst>
+                            <p:childTnLst>
+                              <p:par>
+                                <p:cTn id="11" presetID="1" presetClass="entr" presetSubtype="0" fill="hold" grpId="0" nodeType="clickEffect">
+                                  <p:stCondLst>
+                                    <p:cond delay="0"/>
+                                  </p:stCondLst>
+                                  <p:childTnLst>
+                                    <p:set>
+                                      <p:cBhvr>
+                                        <p:cTn id="12" dur="1" fill="hold">
+                                          <p:stCondLst>
+                                            <p:cond delay="0"/>
+                                          </p:stCondLst>
+                                        </p:cTn>
+                                        <p:tgtEl>
+                                          <p:spTgt spid="906"/>
+                                        </p:tgtEl>
+                                        <p:attrNameLst>
+                                          <p:attrName>style.visibility</p:attrName>
+                                        </p:attrNameLst>
+                                      </p:cBhvr>
+                                      <p:to>
+                                        <p:strVal val="visible"/>
+                                      </p:to>
+                                    </p:set>
+                                  </p:childTnLst>
+                                </p:cTn>
+                              </p:par>
+                              <p:par>
+                                <p:cTn id="13" presetID="1" presetClass="entr" presetSubtype="0" fill="hold" grpId="0" nodeType="withEffect">
+                                  <p:stCondLst>
+                                    <p:cond delay="0"/>
+                                  </p:stCondLst>
+                                  <p:childTnLst>
+                                    <p:set>
+                                      <p:cBhvr>
+                                        <p:cTn id="14" dur="1" fill="hold">
+                                          <p:stCondLst>
+                                            <p:cond delay="0"/>
+                                          </p:stCondLst>
+                                        </p:cTn>
+                                        <p:tgtEl>
+                                          <p:spTgt spid="907"/>
+                                        </p:tgtEl>
+                                        <p:attrNameLst>
+                                          <p:attrName>style.visibility</p:attrName>
+                                        </p:attrNameLst>
+                                      </p:cBhvr>
+                                      <p:to>
+                                        <p:strVal val="visible"/>
+                                      </p:to>
+                                    </p:set>
+                                  </p:childTnLst>
+                                </p:cTn>
+                              </p:par>
+                            </p:childTnLst>
+                          </p:cTn>
+                        </p:par>
+                      </p:childTnLst>
+                    </p:cTn>
+                  </p:par>
+                </p:childTnLst>
+              </p:cTn>
+              <p:prevCondLst>
+                <p:cond evt="onPrev" delay="0">
+                  <p:tgtEl>
+                    <p:sldTgt/>
+                  </p:tgtEl>
+                </p:cond>
+              </p:prevCondLst>
+              <p:nextCondLst>
+                <p:cond evt="onNext" delay="0">
+                  <p:tgtEl>
+                    <p:sldTgt/>
+                  </p:tgtEl>
+                </p:cond>
+              </p:nextCondLst>
+            </p:seq>
+          </p:childTnLst>
+        </p:cTn>
+      </p:par>
+    </p:tnLst>
+    <p:bldLst>
+      <p:bldP spid="904" grpId="0" animBg="1"/>
+      <p:bldP spid="905" grpId="0" animBg="1"/>
+      <p:bldP spid="906" grpId="0" animBg="1"/>
+      <p:bldP spid="907" grpId="0" animBg="1"/>
+    </p:bldLst>
+  </p:timing>
 </p:sld>
 </file>
 
@@ -21311,6 +22176,288 @@
   <p:clrMapOvr>
     <a:masterClrMapping/>
   </p:clrMapOvr>
+  <p:timing>
+    <p:tnLst>
+      <p:par>
+        <p:cTn id="1" dur="indefinite" restart="never" nodeType="tmRoot">
+          <p:childTnLst>
+            <p:seq concurrent="1" nextAc="seek">
+              <p:cTn id="2" dur="indefinite" nodeType="mainSeq">
+                <p:childTnLst>
+                  <p:par>
+                    <p:cTn id="3" fill="hold">
+                      <p:stCondLst>
+                        <p:cond delay="indefinite"/>
+                      </p:stCondLst>
+                      <p:childTnLst>
+                        <p:par>
+                          <p:cTn id="4" fill="hold">
+                            <p:stCondLst>
+                              <p:cond delay="0"/>
+                            </p:stCondLst>
+                            <p:childTnLst>
+                              <p:par>
+                                <p:cTn id="5" presetID="1" presetClass="entr" presetSubtype="0" fill="hold" grpId="0" nodeType="clickEffect">
+                                  <p:stCondLst>
+                                    <p:cond delay="0"/>
+                                  </p:stCondLst>
+                                  <p:childTnLst>
+                                    <p:set>
+                                      <p:cBhvr>
+                                        <p:cTn id="6" dur="1" fill="hold">
+                                          <p:stCondLst>
+                                            <p:cond delay="0"/>
+                                          </p:stCondLst>
+                                        </p:cTn>
+                                        <p:tgtEl>
+                                          <p:spTgt spid="903"/>
+                                        </p:tgtEl>
+                                        <p:attrNameLst>
+                                          <p:attrName>style.visibility</p:attrName>
+                                        </p:attrNameLst>
+                                      </p:cBhvr>
+                                      <p:to>
+                                        <p:strVal val="visible"/>
+                                      </p:to>
+                                    </p:set>
+                                  </p:childTnLst>
+                                </p:cTn>
+                              </p:par>
+                              <p:par>
+                                <p:cTn id="7" presetID="1" presetClass="entr" presetSubtype="0" fill="hold" grpId="0" nodeType="withEffect">
+                                  <p:stCondLst>
+                                    <p:cond delay="0"/>
+                                  </p:stCondLst>
+                                  <p:childTnLst>
+                                    <p:set>
+                                      <p:cBhvr>
+                                        <p:cTn id="8" dur="1" fill="hold">
+                                          <p:stCondLst>
+                                            <p:cond delay="0"/>
+                                          </p:stCondLst>
+                                        </p:cTn>
+                                        <p:tgtEl>
+                                          <p:spTgt spid="904"/>
+                                        </p:tgtEl>
+                                        <p:attrNameLst>
+                                          <p:attrName>style.visibility</p:attrName>
+                                        </p:attrNameLst>
+                                      </p:cBhvr>
+                                      <p:to>
+                                        <p:strVal val="visible"/>
+                                      </p:to>
+                                    </p:set>
+                                  </p:childTnLst>
+                                </p:cTn>
+                              </p:par>
+                            </p:childTnLst>
+                          </p:cTn>
+                        </p:par>
+                      </p:childTnLst>
+                    </p:cTn>
+                  </p:par>
+                  <p:par>
+                    <p:cTn id="9" fill="hold">
+                      <p:stCondLst>
+                        <p:cond delay="indefinite"/>
+                      </p:stCondLst>
+                      <p:childTnLst>
+                        <p:par>
+                          <p:cTn id="10" fill="hold">
+                            <p:stCondLst>
+                              <p:cond delay="0"/>
+                            </p:stCondLst>
+                            <p:childTnLst>
+                              <p:par>
+                                <p:cTn id="11" presetID="1" presetClass="entr" presetSubtype="0" fill="hold" grpId="0" nodeType="clickEffect">
+                                  <p:stCondLst>
+                                    <p:cond delay="0"/>
+                                  </p:stCondLst>
+                                  <p:childTnLst>
+                                    <p:set>
+                                      <p:cBhvr>
+                                        <p:cTn id="12" dur="1" fill="hold">
+                                          <p:stCondLst>
+                                            <p:cond delay="0"/>
+                                          </p:stCondLst>
+                                        </p:cTn>
+                                        <p:tgtEl>
+                                          <p:spTgt spid="905"/>
+                                        </p:tgtEl>
+                                        <p:attrNameLst>
+                                          <p:attrName>style.visibility</p:attrName>
+                                        </p:attrNameLst>
+                                      </p:cBhvr>
+                                      <p:to>
+                                        <p:strVal val="visible"/>
+                                      </p:to>
+                                    </p:set>
+                                  </p:childTnLst>
+                                </p:cTn>
+                              </p:par>
+                              <p:par>
+                                <p:cTn id="13" presetID="1" presetClass="entr" presetSubtype="0" fill="hold" grpId="0" nodeType="withEffect">
+                                  <p:stCondLst>
+                                    <p:cond delay="0"/>
+                                  </p:stCondLst>
+                                  <p:childTnLst>
+                                    <p:set>
+                                      <p:cBhvr>
+                                        <p:cTn id="14" dur="1" fill="hold">
+                                          <p:stCondLst>
+                                            <p:cond delay="0"/>
+                                          </p:stCondLst>
+                                        </p:cTn>
+                                        <p:tgtEl>
+                                          <p:spTgt spid="906"/>
+                                        </p:tgtEl>
+                                        <p:attrNameLst>
+                                          <p:attrName>style.visibility</p:attrName>
+                                        </p:attrNameLst>
+                                      </p:cBhvr>
+                                      <p:to>
+                                        <p:strVal val="visible"/>
+                                      </p:to>
+                                    </p:set>
+                                  </p:childTnLst>
+                                </p:cTn>
+                              </p:par>
+                            </p:childTnLst>
+                          </p:cTn>
+                        </p:par>
+                      </p:childTnLst>
+                    </p:cTn>
+                  </p:par>
+                  <p:par>
+                    <p:cTn id="15" fill="hold">
+                      <p:stCondLst>
+                        <p:cond delay="indefinite"/>
+                      </p:stCondLst>
+                      <p:childTnLst>
+                        <p:par>
+                          <p:cTn id="16" fill="hold">
+                            <p:stCondLst>
+                              <p:cond delay="0"/>
+                            </p:stCondLst>
+                            <p:childTnLst>
+                              <p:par>
+                                <p:cTn id="17" presetID="1" presetClass="entr" presetSubtype="0" fill="hold" grpId="0" nodeType="clickEffect">
+                                  <p:stCondLst>
+                                    <p:cond delay="0"/>
+                                  </p:stCondLst>
+                                  <p:childTnLst>
+                                    <p:set>
+                                      <p:cBhvr>
+                                        <p:cTn id="18" dur="1" fill="hold">
+                                          <p:stCondLst>
+                                            <p:cond delay="0"/>
+                                          </p:stCondLst>
+                                        </p:cTn>
+                                        <p:tgtEl>
+                                          <p:spTgt spid="907"/>
+                                        </p:tgtEl>
+                                        <p:attrNameLst>
+                                          <p:attrName>style.visibility</p:attrName>
+                                        </p:attrNameLst>
+                                      </p:cBhvr>
+                                      <p:to>
+                                        <p:strVal val="visible"/>
+                                      </p:to>
+                                    </p:set>
+                                  </p:childTnLst>
+                                </p:cTn>
+                              </p:par>
+                              <p:par>
+                                <p:cTn id="19" presetID="1" presetClass="entr" presetSubtype="0" fill="hold" grpId="0" nodeType="withEffect">
+                                  <p:stCondLst>
+                                    <p:cond delay="0"/>
+                                  </p:stCondLst>
+                                  <p:childTnLst>
+                                    <p:set>
+                                      <p:cBhvr>
+                                        <p:cTn id="20" dur="1" fill="hold">
+                                          <p:stCondLst>
+                                            <p:cond delay="0"/>
+                                          </p:stCondLst>
+                                        </p:cTn>
+                                        <p:tgtEl>
+                                          <p:spTgt spid="908"/>
+                                        </p:tgtEl>
+                                        <p:attrNameLst>
+                                          <p:attrName>style.visibility</p:attrName>
+                                        </p:attrNameLst>
+                                      </p:cBhvr>
+                                      <p:to>
+                                        <p:strVal val="visible"/>
+                                      </p:to>
+                                    </p:set>
+                                  </p:childTnLst>
+                                </p:cTn>
+                              </p:par>
+                              <p:par>
+                                <p:cTn id="21" presetID="1" presetClass="entr" presetSubtype="0" fill="hold" grpId="0" nodeType="withEffect">
+                                  <p:stCondLst>
+                                    <p:cond delay="0"/>
+                                  </p:stCondLst>
+                                  <p:childTnLst>
+                                    <p:set>
+                                      <p:cBhvr>
+                                        <p:cTn id="22" dur="1" fill="hold">
+                                          <p:stCondLst>
+                                            <p:cond delay="0"/>
+                                          </p:stCondLst>
+                                        </p:cTn>
+                                        <p:tgtEl>
+                                          <p:spTgt spid="909"/>
+                                        </p:tgtEl>
+                                        <p:attrNameLst>
+                                          <p:attrName>style.visibility</p:attrName>
+                                        </p:attrNameLst>
+                                      </p:cBhvr>
+                                      <p:to>
+                                        <p:strVal val="visible"/>
+                                      </p:to>
+                                    </p:set>
+                                  </p:childTnLst>
+                                </p:cTn>
+                              </p:par>
+                            </p:childTnLst>
+                          </p:cTn>
+                        </p:par>
+                      </p:childTnLst>
+                    </p:cTn>
+                  </p:par>
+                </p:childTnLst>
+              </p:cTn>
+              <p:prevCondLst>
+                <p:cond evt="onPrev" delay="0">
+                  <p:tgtEl>
+                    <p:sldTgt/>
+                  </p:tgtEl>
+                </p:cond>
+              </p:prevCondLst>
+              <p:nextCondLst>
+                <p:cond evt="onNext" delay="0">
+                  <p:tgtEl>
+                    <p:sldTgt/>
+                  </p:tgtEl>
+                </p:cond>
+              </p:nextCondLst>
+            </p:seq>
+          </p:childTnLst>
+        </p:cTn>
+      </p:par>
+    </p:tnLst>
+    <p:bldLst>
+      <p:bldP spid="903" grpId="0" animBg="1"/>
+      <p:bldP spid="904" grpId="0" animBg="1"/>
+      <p:bldP spid="905" grpId="0" animBg="1"/>
+      <p:bldP spid="906" grpId="0" animBg="1"/>
+      <p:bldP spid="907" grpId="0" animBg="1"/>
+      <p:bldP spid="908" grpId="0" animBg="1"/>
+      <p:bldP spid="909" grpId="0" animBg="1"/>
+    </p:bldLst>
+  </p:timing>
 </p:sld>
 </file>
 
@@ -21531,6 +22678,84 @@
   <p:clrMapOvr>
     <a:masterClrMapping/>
   </p:clrMapOvr>
+  <p:timing>
+    <p:tnLst>
+      <p:par>
+        <p:cTn id="1" dur="indefinite" restart="never" nodeType="tmRoot">
+          <p:childTnLst>
+            <p:seq concurrent="1" nextAc="seek">
+              <p:cTn id="2" dur="indefinite" nodeType="mainSeq">
+                <p:childTnLst>
+                  <p:par>
+                    <p:cTn id="3" fill="hold">
+                      <p:stCondLst>
+                        <p:cond delay="indefinite"/>
+                      </p:stCondLst>
+                      <p:childTnLst>
+                        <p:par>
+                          <p:cTn id="4" fill="hold">
+                            <p:stCondLst>
+                              <p:cond delay="0"/>
+                            </p:stCondLst>
+                            <p:childTnLst>
+                              <p:par>
+                                <p:cTn id="5" presetID="1" presetClass="entr" presetSubtype="0" fill="hold" grpId="0" nodeType="clickEffect">
+                                  <p:stCondLst>
+                                    <p:cond delay="0"/>
+                                  </p:stCondLst>
+                                  <p:childTnLst>
+                                    <p:set>
+                                      <p:cBhvr>
+                                        <p:cTn id="6" dur="1" fill="hold">
+                                          <p:stCondLst>
+                                            <p:cond delay="0"/>
+                                          </p:stCondLst>
+                                        </p:cTn>
+                                        <p:tgtEl>
+                                          <p:spTgt spid="3"/>
+                                        </p:tgtEl>
+                                        <p:attrNameLst>
+                                          <p:attrName>style.visibility</p:attrName>
+                                        </p:attrNameLst>
+                                      </p:cBhvr>
+                                      <p:to>
+                                        <p:strVal val="visible"/>
+                                      </p:to>
+                                    </p:set>
+                                  </p:childTnLst>
+                                </p:cTn>
+                              </p:par>
+                            </p:childTnLst>
+                          </p:cTn>
+                        </p:par>
+                      </p:childTnLst>
+                    </p:cTn>
+                  </p:par>
+                </p:childTnLst>
+              </p:cTn>
+              <p:prevCondLst>
+                <p:cond evt="onPrev" delay="0">
+                  <p:tgtEl>
+                    <p:sldTgt/>
+                  </p:tgtEl>
+                </p:cond>
+              </p:prevCondLst>
+              <p:nextCondLst>
+                <p:cond evt="onNext" delay="0">
+                  <p:tgtEl>
+                    <p:sldTgt/>
+                  </p:tgtEl>
+                </p:cond>
+              </p:nextCondLst>
+            </p:seq>
+          </p:childTnLst>
+        </p:cTn>
+      </p:par>
+    </p:tnLst>
+    <p:bldLst>
+      <p:bldP spid="3" grpId="0" animBg="1"/>
+    </p:bldLst>
+  </p:timing>
 </p:sld>
 </file>
 

</xml_diff>

<commit_message>
Pitch deck (static): top-10 figure 91% -> 88% on slides 8 and 13
Co-Authored-By: Claude Opus 5.5 <noreply@anthropic.com>
</commit_message>
<xml_diff>
--- a/research/Mutz_Pitch_lean_static.pptx
+++ b/research/Mutz_Pitch_lean_static.pptx
@@ -9889,7 +9889,7 @@
                   <a:srgbClr val="000000"/>
                 </a:solidFill>
               </a:rPr>
-              <a:t>91%</a:t>
+              <a:t>88%</a:t>
             </a:r>
           </a:p>
         </p:txBody>
@@ -21938,7 +21938,7 @@
                   <a:srgbClr val="000000"/>
                 </a:solidFill>
               </a:rPr>
-              <a:t>91%</a:t>
+              <a:t>88%</a:t>
             </a:r>
           </a:p>
         </p:txBody>

</xml_diff>